<commit_message>
Add Fraud Detection Portal slides to hackathon presentation (15 slides)
Added 2 new slides:
- Slide 11: Fraud Detection — 4 check types: Bank Statement Tampering (balance
  reconciliation gate), Identity Fraud (PAN/mobile dedupe, name match), GST
  Mismatch (GSTIN-PAN cross-check, turnover variance), Document Completeness
- Slide 12: Fraud Attention Panel — severity-ranked findings (HIGH/MEDIUM/LOW),
  structured evidence format with confidence scores, auditable trail

Updated:
- Roadmap includes Fraud Detection v2 (ML-based tamper detection)
- Tech Stack adds Fraud Engine row
- Slide numbers adjusted (now 15 slides total)

Co-Authored-By: Claude Opus 4.6 <noreply@anthropic.com>
</commit_message>
<xml_diff>
--- a/presentation/Slice3.0_EDL_Copilot.pptx
+++ b/presentation/Slice3.0_EDL_Copilot.pptx
@@ -18,9 +18,11 @@
     <p:sldId id="266" r:id="rId12"/>
     <p:sldId id="267" r:id="rId13"/>
     <p:sldId id="268" r:id="rId14"/>
+    <p:sldId id="269" r:id="rId15"/>
+    <p:sldId id="270" r:id="rId16"/>
   </p:sldIdLst>
   <p:notesMasterIdLst>
-    <p:notesMasterId r:id="rId15"/>
+    <p:notesMasterId r:id="rId17"/>
   </p:notesMasterIdLst>
   <p:sldSz cx="9144000" cy="5143500"/>
   <p:notesSz cx="5143500" cy="9144000"/>
@@ -890,6 +892,182 @@
             <a:fld id="{F7021451-1387-4CA6-816F-3879F97B5CBC}" type="slidenum">
               <a:rPr lang="en-US"/>
               <a:t>13</a:t>
+            </a:fld>
+            <a:endParaRPr lang="en-US"/>
+          </a:p>
+        </p:txBody>
+      </p:sp>
+    </p:spTree>
+    <p:extLst>
+      <p:ext uri="{BB962C8B-B14F-4D97-AF65-F5344CB8AC3E}">
+        <p14:creationId xmlns:p14="http://schemas.microsoft.com/office/powerpoint/2010/main" val="1024086991"/>
+      </p:ext>
+    </p:extLst>
+  </p:cSld>
+  <p:clrMapOvr>
+    <a:masterClrMapping/>
+  </p:clrMapOvr>
+</p:notes>
+</file>
+
+<file path=ppt/notesSlides/notesSlide14.xml><?xml version="1.0" encoding="utf-8"?>
+<p:notes xmlns:a="http://schemas.openxmlformats.org/drawingml/2006/main" xmlns:r="http://schemas.openxmlformats.org/officeDocument/2006/relationships" xmlns:p="http://schemas.openxmlformats.org/presentationml/2006/main">
+  <p:cSld>
+    <p:spTree>
+      <p:nvGrpSpPr>
+        <p:cNvPr id="1" name=""/>
+        <p:cNvGrpSpPr/>
+        <p:nvPr/>
+      </p:nvGrpSpPr>
+      <p:grpSpPr>
+        <a:xfrm>
+          <a:off x="0" y="0"/>
+          <a:ext cx="0" cy="0"/>
+          <a:chOff x="0" y="0"/>
+          <a:chExt cx="0" cy="0"/>
+        </a:xfrm>
+      </p:grpSpPr>
+      <p:sp>
+        <p:nvSpPr>
+          <p:cNvPr id="2" name="Slide Image Placeholder 1"/>
+          <p:cNvSpPr>
+            <a:spLocks noGrp="1" noRot="1" noChangeAspect="1"/>
+          </p:cNvSpPr>
+          <p:nvPr>
+            <p:ph type="sldImg"/>
+          </p:nvPr>
+        </p:nvSpPr>
+        <p:spPr/>
+      </p:sp>
+      <p:sp>
+        <p:nvSpPr>
+          <p:cNvPr id="3" name="Notes Placeholder 2"/>
+          <p:cNvSpPr>
+            <a:spLocks noGrp="1"/>
+          </p:cNvSpPr>
+          <p:nvPr>
+            <p:ph type="body" idx="1"/>
+          </p:nvPr>
+        </p:nvSpPr>
+        <p:spPr/>
+        <p:txBody>
+          <a:bodyPr/>
+          <a:lstStyle/>
+          <a:p>
+            <a:r>
+              <a:rPr lang="en-US" dirty="0"/>
+              <a:t/>
+            </a:r>
+            <a:endParaRPr lang="en-US" dirty="0"/>
+          </a:p>
+        </p:txBody>
+      </p:sp>
+      <p:sp>
+        <p:nvSpPr>
+          <p:cNvPr id="4" name="Slide Number Placeholder 3"/>
+          <p:cNvSpPr>
+            <a:spLocks noGrp="1"/>
+          </p:cNvSpPr>
+          <p:nvPr>
+            <p:ph type="sldNum" sz="quarter" idx="10"/>
+          </p:nvPr>
+        </p:nvSpPr>
+        <p:spPr/>
+        <p:txBody>
+          <a:bodyPr/>
+          <a:lstStyle/>
+          <a:p>
+            <a:fld id="{F7021451-1387-4CA6-816F-3879F97B5CBC}" type="slidenum">
+              <a:rPr lang="en-US"/>
+              <a:t>14</a:t>
+            </a:fld>
+            <a:endParaRPr lang="en-US"/>
+          </a:p>
+        </p:txBody>
+      </p:sp>
+    </p:spTree>
+    <p:extLst>
+      <p:ext uri="{BB962C8B-B14F-4D97-AF65-F5344CB8AC3E}">
+        <p14:creationId xmlns:p14="http://schemas.microsoft.com/office/powerpoint/2010/main" val="1024086991"/>
+      </p:ext>
+    </p:extLst>
+  </p:cSld>
+  <p:clrMapOvr>
+    <a:masterClrMapping/>
+  </p:clrMapOvr>
+</p:notes>
+</file>
+
+<file path=ppt/notesSlides/notesSlide15.xml><?xml version="1.0" encoding="utf-8"?>
+<p:notes xmlns:a="http://schemas.openxmlformats.org/drawingml/2006/main" xmlns:r="http://schemas.openxmlformats.org/officeDocument/2006/relationships" xmlns:p="http://schemas.openxmlformats.org/presentationml/2006/main">
+  <p:cSld>
+    <p:spTree>
+      <p:nvGrpSpPr>
+        <p:cNvPr id="1" name=""/>
+        <p:cNvGrpSpPr/>
+        <p:nvPr/>
+      </p:nvGrpSpPr>
+      <p:grpSpPr>
+        <a:xfrm>
+          <a:off x="0" y="0"/>
+          <a:ext cx="0" cy="0"/>
+          <a:chOff x="0" y="0"/>
+          <a:chExt cx="0" cy="0"/>
+        </a:xfrm>
+      </p:grpSpPr>
+      <p:sp>
+        <p:nvSpPr>
+          <p:cNvPr id="2" name="Slide Image Placeholder 1"/>
+          <p:cNvSpPr>
+            <a:spLocks noGrp="1" noRot="1" noChangeAspect="1"/>
+          </p:cNvSpPr>
+          <p:nvPr>
+            <p:ph type="sldImg"/>
+          </p:nvPr>
+        </p:nvSpPr>
+        <p:spPr/>
+      </p:sp>
+      <p:sp>
+        <p:nvSpPr>
+          <p:cNvPr id="3" name="Notes Placeholder 2"/>
+          <p:cNvSpPr>
+            <a:spLocks noGrp="1"/>
+          </p:cNvSpPr>
+          <p:nvPr>
+            <p:ph type="body" idx="1"/>
+          </p:nvPr>
+        </p:nvSpPr>
+        <p:spPr/>
+        <p:txBody>
+          <a:bodyPr/>
+          <a:lstStyle/>
+          <a:p>
+            <a:r>
+              <a:rPr lang="en-US" dirty="0"/>
+              <a:t/>
+            </a:r>
+            <a:endParaRPr lang="en-US" dirty="0"/>
+          </a:p>
+        </p:txBody>
+      </p:sp>
+      <p:sp>
+        <p:nvSpPr>
+          <p:cNvPr id="4" name="Slide Number Placeholder 3"/>
+          <p:cNvSpPr>
+            <a:spLocks noGrp="1"/>
+          </p:cNvSpPr>
+          <p:nvPr>
+            <p:ph type="sldNum" sz="quarter" idx="10"/>
+          </p:nvPr>
+        </p:nvSpPr>
+        <p:spPr/>
+        <p:txBody>
+          <a:bodyPr/>
+          <a:lstStyle/>
+          <a:p>
+            <a:fld id="{F7021451-1387-4CA6-816F-3879F97B5CBC}" type="slidenum">
+              <a:rPr lang="en-US"/>
+              <a:t>15</a:t>
             </a:fld>
             <a:endParaRPr lang="en-US"/>
           </a:p>
@@ -2540,7 +2718,7 @@
                 <a:ea typeface="Arial Black" pitchFamily="34" charset="-122"/>
                 <a:cs typeface="Arial Black" pitchFamily="34" charset="-120"/>
               </a:rPr>
-              <a:t>Business Impact</a:t>
+              <a:t>Fraud Detection: Built Into the Pipeline</a:t>
             </a:r>
             <a:endParaRPr lang="en-US" sz="2800" dirty="0"/>
           </a:p>
@@ -2579,7 +2757,7 @@
                 <a:ea typeface="Calibri" pitchFamily="34" charset="-122"/>
                 <a:cs typeface="Calibri" pitchFamily="34" charset="-120"/>
               </a:rPr>
-              <a:t>Primary lever: underwriter bandwidth → operations cost</a:t>
+              <a:t>Automated checks that are impossible to skip — applied consistently on every application</a:t>
             </a:r>
             <a:endParaRPr lang="en-US" sz="1300" dirty="0"/>
           </a:p>
@@ -2632,16 +2810,16 @@
         </p:nvSpPr>
         <p:spPr>
           <a:xfrm>
-            <a:off x="457200" y="1417320"/>
-            <a:ext cx="1965960" cy="1508760"/>
+            <a:off x="640080" y="1417320"/>
+            <a:ext cx="3840480" cy="1417320"/>
           </a:xfrm>
           <a:prstGeom prst="roundRect">
             <a:avLst>
-              <a:gd name="adj" fmla="val 4848"/>
+              <a:gd name="adj" fmla="val 5161"/>
             </a:avLst>
           </a:prstGeom>
           <a:solidFill>
-            <a:srgbClr val="F4F5F7"/>
+            <a:srgbClr val="FEE2E2"/>
           </a:solidFill>
           <a:ln/>
           <a:effectLst>
@@ -2655,42 +2833,23 @@
       </p:sp>
       <p:sp>
         <p:nvSpPr>
-          <p:cNvPr id="7" name="Text 5"/>
-          <p:cNvSpPr/>
-          <p:nvPr/>
-        </p:nvSpPr>
-        <p:spPr>
-          <a:xfrm>
-            <a:off x="457200" y="1508760"/>
-            <a:ext cx="1965960" cy="457200"/>
-          </a:xfrm>
-          <a:prstGeom prst="rect">
-            <a:avLst/>
-          </a:prstGeom>
-          <a:noFill/>
-          <a:ln/>
-        </p:spPr>
-        <p:txBody>
-          <a:bodyPr wrap="square" lIns="0" tIns="0" rIns="0" bIns="0" rtlCol="0" anchor="ctr"/>
-          <a:lstStyle/>
-          <a:p>
-            <a:pPr algn="ctr" indent="0" marL="0">
-              <a:buNone/>
-            </a:pPr>
-            <a:r>
-              <a:rPr lang="en-US" sz="2400" dirty="0">
-                <a:solidFill>
-                  <a:srgbClr val="3B82F6"/>
-                </a:solidFill>
-                <a:latin typeface="Arial Black" pitchFamily="34" charset="0"/>
-                <a:ea typeface="Arial Black" pitchFamily="34" charset="-122"/>
-                <a:cs typeface="Arial Black" pitchFamily="34" charset="-120"/>
-              </a:rPr>
-              <a:t>1-2 hrs</a:t>
-            </a:r>
-            <a:endParaRPr lang="en-US" sz="2400" dirty="0"/>
-          </a:p>
-        </p:txBody>
+          <p:cNvPr id="7" name="Shape 5"/>
+          <p:cNvSpPr/>
+          <p:nvPr/>
+        </p:nvSpPr>
+        <p:spPr>
+          <a:xfrm>
+            <a:off x="640080" y="1417320"/>
+            <a:ext cx="73152" cy="1417320"/>
+          </a:xfrm>
+          <a:prstGeom prst="rect">
+            <a:avLst/>
+          </a:prstGeom>
+          <a:solidFill>
+            <a:srgbClr val="DC2626"/>
+          </a:solidFill>
+          <a:ln/>
+        </p:spPr>
       </p:sp>
       <p:sp>
         <p:nvSpPr>
@@ -2700,32 +2859,74 @@
         </p:nvSpPr>
         <p:spPr>
           <a:xfrm>
-            <a:off x="548640" y="2011680"/>
-            <a:ext cx="1783080" cy="365760"/>
-          </a:xfrm>
-          <a:prstGeom prst="rect">
-            <a:avLst/>
-          </a:prstGeom>
-          <a:noFill/>
-          <a:ln/>
-        </p:spPr>
-        <p:txBody>
-          <a:bodyPr wrap="square" lIns="0" tIns="0" rIns="0" bIns="0" rtlCol="0" anchor="ctr"/>
-          <a:lstStyle/>
-          <a:p>
-            <a:pPr algn="ctr" indent="0" marL="0">
-              <a:buNone/>
-            </a:pPr>
-            <a:r>
-              <a:rPr lang="en-US" sz="1000" b="1" dirty="0">
+            <a:off x="868680" y="1508760"/>
+            <a:ext cx="3474720" cy="274320"/>
+          </a:xfrm>
+          <a:prstGeom prst="rect">
+            <a:avLst/>
+          </a:prstGeom>
+          <a:noFill/>
+          <a:ln/>
+        </p:spPr>
+        <p:txBody>
+          <a:bodyPr wrap="square" lIns="0" tIns="0" rIns="0" bIns="0" rtlCol="0" anchor="ctr"/>
+          <a:lstStyle/>
+          <a:p>
+            <a:pPr indent="0" marL="0">
+              <a:buNone/>
+            </a:pPr>
+            <a:r>
+              <a:rPr lang="en-US" sz="1300" b="1" dirty="0">
                 <a:solidFill>
                   <a:srgbClr val="111827"/>
+                </a:solidFill>
+                <a:latin typeface="Arial" pitchFamily="34" charset="0"/>
+                <a:ea typeface="Arial" pitchFamily="34" charset="-122"/>
+                <a:cs typeface="Arial" pitchFamily="34" charset="-120"/>
+              </a:rPr>
+              <a:t>🔍  Bank Statement Tampering</a:t>
+            </a:r>
+            <a:endParaRPr lang="en-US" sz="1300" dirty="0"/>
+          </a:p>
+        </p:txBody>
+      </p:sp>
+      <p:sp>
+        <p:nvSpPr>
+          <p:cNvPr id="9" name="Text 7"/>
+          <p:cNvSpPr/>
+          <p:nvPr/>
+        </p:nvSpPr>
+        <p:spPr>
+          <a:xfrm>
+            <a:off x="868680" y="1874520"/>
+            <a:ext cx="3474720" cy="822960"/>
+          </a:xfrm>
+          <a:prstGeom prst="rect">
+            <a:avLst/>
+          </a:prstGeom>
+          <a:noFill/>
+          <a:ln/>
+        </p:spPr>
+        <p:txBody>
+          <a:bodyPr wrap="square" lIns="0" tIns="0" rIns="0" bIns="0" rtlCol="0" anchor="ctr"/>
+          <a:lstStyle/>
+          <a:p>
+            <a:pPr indent="0" marL="0">
+              <a:lnSpc>
+                <a:spcPct val="130000"/>
+              </a:lnSpc>
+              <a:buNone/>
+            </a:pPr>
+            <a:r>
+              <a:rPr lang="en-US" sz="1000" dirty="0">
+                <a:solidFill>
+                  <a:srgbClr val="374151"/>
                 </a:solidFill>
                 <a:latin typeface="Calibri" pitchFamily="34" charset="0"/>
                 <a:ea typeface="Calibri" pitchFamily="34" charset="-122"/>
                 <a:cs typeface="Calibri" pitchFamily="34" charset="-120"/>
               </a:rPr>
-              <a:t>saved per unparseable statement</a:t>
+              <a:t>Balance reconciliation gate detects modified transactions — if balanceₙ ≠ balanceₙ₋₁ ± amount, flag it. Font/pixel analysis for PDF manipulation.</a:t>
             </a:r>
             <a:endParaRPr lang="en-US" sz="1000" dirty="0"/>
           </a:p>
@@ -2733,61 +2934,22 @@
       </p:sp>
       <p:sp>
         <p:nvSpPr>
-          <p:cNvPr id="9" name="Text 7"/>
-          <p:cNvSpPr/>
-          <p:nvPr/>
-        </p:nvSpPr>
-        <p:spPr>
-          <a:xfrm>
-            <a:off x="548640" y="2377440"/>
-            <a:ext cx="1783080" cy="320040"/>
-          </a:xfrm>
-          <a:prstGeom prst="rect">
-            <a:avLst/>
-          </a:prstGeom>
-          <a:noFill/>
-          <a:ln/>
-        </p:spPr>
-        <p:txBody>
-          <a:bodyPr wrap="square" lIns="0" tIns="0" rIns="0" bIns="0" rtlCol="0" anchor="ctr"/>
-          <a:lstStyle/>
-          <a:p>
-            <a:pPr algn="ctr" indent="0" marL="0">
-              <a:buNone/>
-            </a:pPr>
-            <a:r>
-              <a:rPr lang="en-US" sz="900" dirty="0">
-                <a:solidFill>
-                  <a:srgbClr val="6B7280"/>
-                </a:solidFill>
-                <a:latin typeface="Calibri" pitchFamily="34" charset="0"/>
-                <a:ea typeface="Calibri" pitchFamily="34" charset="-122"/>
-                <a:cs typeface="Calibri" pitchFamily="34" charset="-120"/>
-              </a:rPr>
-              <a:t>~20% of all cases</a:t>
-            </a:r>
-            <a:endParaRPr lang="en-US" sz="900" dirty="0"/>
-          </a:p>
-        </p:txBody>
-      </p:sp>
-      <p:sp>
-        <p:nvSpPr>
           <p:cNvPr id="10" name="Shape 8"/>
           <p:cNvSpPr/>
           <p:nvPr/>
         </p:nvSpPr>
         <p:spPr>
           <a:xfrm>
-            <a:off x="2606040" y="1417320"/>
-            <a:ext cx="1965960" cy="1508760"/>
+            <a:off x="4754880" y="1417320"/>
+            <a:ext cx="3840480" cy="1417320"/>
           </a:xfrm>
           <a:prstGeom prst="roundRect">
             <a:avLst>
-              <a:gd name="adj" fmla="val 4848"/>
+              <a:gd name="adj" fmla="val 5161"/>
             </a:avLst>
           </a:prstGeom>
           <a:solidFill>
-            <a:srgbClr val="F4F5F7"/>
+            <a:srgbClr val="FEF3C7"/>
           </a:solidFill>
           <a:ln/>
           <a:effectLst>
@@ -2801,42 +2963,23 @@
       </p:sp>
       <p:sp>
         <p:nvSpPr>
-          <p:cNvPr id="11" name="Text 9"/>
-          <p:cNvSpPr/>
-          <p:nvPr/>
-        </p:nvSpPr>
-        <p:spPr>
-          <a:xfrm>
-            <a:off x="2606040" y="1508760"/>
-            <a:ext cx="1965960" cy="457200"/>
-          </a:xfrm>
-          <a:prstGeom prst="rect">
-            <a:avLst/>
-          </a:prstGeom>
-          <a:noFill/>
-          <a:ln/>
-        </p:spPr>
-        <p:txBody>
-          <a:bodyPr wrap="square" lIns="0" tIns="0" rIns="0" bIns="0" rtlCol="0" anchor="ctr"/>
-          <a:lstStyle/>
-          <a:p>
-            <a:pPr algn="ctr" indent="0" marL="0">
-              <a:buNone/>
-            </a:pPr>
-            <a:r>
-              <a:rPr lang="en-US" sz="2400" dirty="0">
-                <a:solidFill>
-                  <a:srgbClr val="3B82F6"/>
-                </a:solidFill>
-                <a:latin typeface="Arial Black" pitchFamily="34" charset="0"/>
-                <a:ea typeface="Arial Black" pitchFamily="34" charset="-122"/>
-                <a:cs typeface="Arial Black" pitchFamily="34" charset="-120"/>
-              </a:rPr>
-              <a:t>15 min</a:t>
-            </a:r>
-            <a:endParaRPr lang="en-US" sz="2400" dirty="0"/>
-          </a:p>
-        </p:txBody>
+          <p:cNvPr id="11" name="Shape 9"/>
+          <p:cNvSpPr/>
+          <p:nvPr/>
+        </p:nvSpPr>
+        <p:spPr>
+          <a:xfrm>
+            <a:off x="4754880" y="1417320"/>
+            <a:ext cx="73152" cy="1417320"/>
+          </a:xfrm>
+          <a:prstGeom prst="rect">
+            <a:avLst/>
+          </a:prstGeom>
+          <a:solidFill>
+            <a:srgbClr val="F59E0B"/>
+          </a:solidFill>
+          <a:ln/>
+        </p:spPr>
       </p:sp>
       <p:sp>
         <p:nvSpPr>
@@ -2846,32 +2989,74 @@
         </p:nvSpPr>
         <p:spPr>
           <a:xfrm>
-            <a:off x="2697480" y="2011680"/>
-            <a:ext cx="1783080" cy="365760"/>
-          </a:xfrm>
-          <a:prstGeom prst="rect">
-            <a:avLst/>
-          </a:prstGeom>
-          <a:noFill/>
-          <a:ln/>
-        </p:spPr>
-        <p:txBody>
-          <a:bodyPr wrap="square" lIns="0" tIns="0" rIns="0" bIns="0" rtlCol="0" anchor="ctr"/>
-          <a:lstStyle/>
-          <a:p>
-            <a:pPr algn="ctr" indent="0" marL="0">
-              <a:buNone/>
-            </a:pPr>
-            <a:r>
-              <a:rPr lang="en-US" sz="1000" b="1" dirty="0">
+            <a:off x="4983480" y="1508760"/>
+            <a:ext cx="3474720" cy="274320"/>
+          </a:xfrm>
+          <a:prstGeom prst="rect">
+            <a:avLst/>
+          </a:prstGeom>
+          <a:noFill/>
+          <a:ln/>
+        </p:spPr>
+        <p:txBody>
+          <a:bodyPr wrap="square" lIns="0" tIns="0" rIns="0" bIns="0" rtlCol="0" anchor="ctr"/>
+          <a:lstStyle/>
+          <a:p>
+            <a:pPr indent="0" marL="0">
+              <a:buNone/>
+            </a:pPr>
+            <a:r>
+              <a:rPr lang="en-US" sz="1300" b="1" dirty="0">
                 <a:solidFill>
                   <a:srgbClr val="111827"/>
+                </a:solidFill>
+                <a:latin typeface="Arial" pitchFamily="34" charset="0"/>
+                <a:ea typeface="Arial" pitchFamily="34" charset="-122"/>
+                <a:cs typeface="Arial" pitchFamily="34" charset="-120"/>
+              </a:rPr>
+              <a:t>🆔  Identity Fraud Detection</a:t>
+            </a:r>
+            <a:endParaRPr lang="en-US" sz="1300" dirty="0"/>
+          </a:p>
+        </p:txBody>
+      </p:sp>
+      <p:sp>
+        <p:nvSpPr>
+          <p:cNvPr id="13" name="Text 11"/>
+          <p:cNvSpPr/>
+          <p:nvPr/>
+        </p:nvSpPr>
+        <p:spPr>
+          <a:xfrm>
+            <a:off x="4983480" y="1874520"/>
+            <a:ext cx="3474720" cy="822960"/>
+          </a:xfrm>
+          <a:prstGeom prst="rect">
+            <a:avLst/>
+          </a:prstGeom>
+          <a:noFill/>
+          <a:ln/>
+        </p:spPr>
+        <p:txBody>
+          <a:bodyPr wrap="square" lIns="0" tIns="0" rIns="0" bIns="0" rtlCol="0" anchor="ctr"/>
+          <a:lstStyle/>
+          <a:p>
+            <a:pPr indent="0" marL="0">
+              <a:lnSpc>
+                <a:spcPct val="130000"/>
+              </a:lnSpc>
+              <a:buNone/>
+            </a:pPr>
+            <a:r>
+              <a:rPr lang="en-US" sz="1000" dirty="0">
+                <a:solidFill>
+                  <a:srgbClr val="374151"/>
                 </a:solidFill>
                 <a:latin typeface="Calibri" pitchFamily="34" charset="0"/>
                 <a:ea typeface="Calibri" pitchFamily="34" charset="-122"/>
                 <a:cs typeface="Calibri" pitchFamily="34" charset="-120"/>
               </a:rPr>
-              <a:t>review replaces manual CAM fill</a:t>
+              <a:t>PAN/mobile dedupe across applicant &amp; co-applicant. Cross-check PAN embedded in GSTIN. Name match between bank statement holder and applicant.</a:t>
             </a:r>
             <a:endParaRPr lang="en-US" sz="1000" dirty="0"/>
           </a:p>
@@ -2879,61 +3064,22 @@
       </p:sp>
       <p:sp>
         <p:nvSpPr>
-          <p:cNvPr id="13" name="Text 11"/>
-          <p:cNvSpPr/>
-          <p:nvPr/>
-        </p:nvSpPr>
-        <p:spPr>
-          <a:xfrm>
-            <a:off x="2697480" y="2377440"/>
-            <a:ext cx="1783080" cy="320040"/>
-          </a:xfrm>
-          <a:prstGeom prst="rect">
-            <a:avLst/>
-          </a:prstGeom>
-          <a:noFill/>
-          <a:ln/>
-        </p:spPr>
-        <p:txBody>
-          <a:bodyPr wrap="square" lIns="0" tIns="0" rIns="0" bIns="0" rtlCol="0" anchor="ctr"/>
-          <a:lstStyle/>
-          <a:p>
-            <a:pPr algn="ctr" indent="0" marL="0">
-              <a:buNone/>
-            </a:pPr>
-            <a:r>
-              <a:rPr lang="en-US" sz="900" dirty="0">
-                <a:solidFill>
-                  <a:srgbClr val="6B7280"/>
-                </a:solidFill>
-                <a:latin typeface="Calibri" pitchFamily="34" charset="0"/>
-                <a:ea typeface="Calibri" pitchFamily="34" charset="-122"/>
-                <a:cs typeface="Calibri" pitchFamily="34" charset="-120"/>
-              </a:rPr>
-              <a:t>from hours → minutes</a:t>
-            </a:r>
-            <a:endParaRPr lang="en-US" sz="900" dirty="0"/>
-          </a:p>
-        </p:txBody>
-      </p:sp>
-      <p:sp>
-        <p:nvSpPr>
           <p:cNvPr id="14" name="Shape 12"/>
           <p:cNvSpPr/>
           <p:nvPr/>
         </p:nvSpPr>
         <p:spPr>
           <a:xfrm>
-            <a:off x="4754880" y="1417320"/>
-            <a:ext cx="1965960" cy="1508760"/>
+            <a:off x="640080" y="3063240"/>
+            <a:ext cx="3840480" cy="1417320"/>
           </a:xfrm>
           <a:prstGeom prst="roundRect">
             <a:avLst>
-              <a:gd name="adj" fmla="val 4848"/>
+              <a:gd name="adj" fmla="val 5161"/>
             </a:avLst>
           </a:prstGeom>
           <a:solidFill>
-            <a:srgbClr val="F4F5F7"/>
+            <a:srgbClr val="EBF5FF"/>
           </a:solidFill>
           <a:ln/>
           <a:effectLst>
@@ -2947,42 +3093,23 @@
       </p:sp>
       <p:sp>
         <p:nvSpPr>
-          <p:cNvPr id="15" name="Text 13"/>
-          <p:cNvSpPr/>
-          <p:nvPr/>
-        </p:nvSpPr>
-        <p:spPr>
-          <a:xfrm>
-            <a:off x="4754880" y="1508760"/>
-            <a:ext cx="1965960" cy="457200"/>
-          </a:xfrm>
-          <a:prstGeom prst="rect">
-            <a:avLst/>
-          </a:prstGeom>
-          <a:noFill/>
-          <a:ln/>
-        </p:spPr>
-        <p:txBody>
-          <a:bodyPr wrap="square" lIns="0" tIns="0" rIns="0" bIns="0" rtlCol="0" anchor="ctr"/>
-          <a:lstStyle/>
-          <a:p>
-            <a:pPr algn="ctr" indent="0" marL="0">
-              <a:buNone/>
-            </a:pPr>
-            <a:r>
-              <a:rPr lang="en-US" sz="2400" dirty="0">
-                <a:solidFill>
-                  <a:srgbClr val="3B82F6"/>
-                </a:solidFill>
-                <a:latin typeface="Arial Black" pitchFamily="34" charset="0"/>
-                <a:ea typeface="Arial Black" pitchFamily="34" charset="-122"/>
-                <a:cs typeface="Arial Black" pitchFamily="34" charset="-120"/>
-              </a:rPr>
-              <a:t>100%</a:t>
-            </a:r>
-            <a:endParaRPr lang="en-US" sz="2400" dirty="0"/>
-          </a:p>
-        </p:txBody>
+          <p:cNvPr id="15" name="Shape 13"/>
+          <p:cNvSpPr/>
+          <p:nvPr/>
+        </p:nvSpPr>
+        <p:spPr>
+          <a:xfrm>
+            <a:off x="640080" y="3063240"/>
+            <a:ext cx="73152" cy="1417320"/>
+          </a:xfrm>
+          <a:prstGeom prst="rect">
+            <a:avLst/>
+          </a:prstGeom>
+          <a:solidFill>
+            <a:srgbClr val="3B82F6"/>
+          </a:solidFill>
+          <a:ln/>
+        </p:spPr>
       </p:sp>
       <p:sp>
         <p:nvSpPr>
@@ -2992,32 +3119,74 @@
         </p:nvSpPr>
         <p:spPr>
           <a:xfrm>
-            <a:off x="4846320" y="2011680"/>
-            <a:ext cx="1783080" cy="365760"/>
-          </a:xfrm>
-          <a:prstGeom prst="rect">
-            <a:avLst/>
-          </a:prstGeom>
-          <a:noFill/>
-          <a:ln/>
-        </p:spPr>
-        <p:txBody>
-          <a:bodyPr wrap="square" lIns="0" tIns="0" rIns="0" bIns="0" rtlCol="0" anchor="ctr"/>
-          <a:lstStyle/>
-          <a:p>
-            <a:pPr algn="ctr" indent="0" marL="0">
-              <a:buNone/>
-            </a:pPr>
-            <a:r>
-              <a:rPr lang="en-US" sz="1000" b="1" dirty="0">
+            <a:off x="868680" y="3154680"/>
+            <a:ext cx="3474720" cy="274320"/>
+          </a:xfrm>
+          <a:prstGeom prst="rect">
+            <a:avLst/>
+          </a:prstGeom>
+          <a:noFill/>
+          <a:ln/>
+        </p:spPr>
+        <p:txBody>
+          <a:bodyPr wrap="square" lIns="0" tIns="0" rIns="0" bIns="0" rtlCol="0" anchor="ctr"/>
+          <a:lstStyle/>
+          <a:p>
+            <a:pPr indent="0" marL="0">
+              <a:buNone/>
+            </a:pPr>
+            <a:r>
+              <a:rPr lang="en-US" sz="1300" b="1" dirty="0">
                 <a:solidFill>
                   <a:srgbClr val="111827"/>
+                </a:solidFill>
+                <a:latin typeface="Arial" pitchFamily="34" charset="0"/>
+                <a:ea typeface="Arial" pitchFamily="34" charset="-122"/>
+                <a:cs typeface="Arial" pitchFamily="34" charset="-120"/>
+              </a:rPr>
+              <a:t>📊  GST Mismatch Detection</a:t>
+            </a:r>
+            <a:endParaRPr lang="en-US" sz="1300" dirty="0"/>
+          </a:p>
+        </p:txBody>
+      </p:sp>
+      <p:sp>
+        <p:nvSpPr>
+          <p:cNvPr id="17" name="Text 15"/>
+          <p:cNvSpPr/>
+          <p:nvPr/>
+        </p:nvSpPr>
+        <p:spPr>
+          <a:xfrm>
+            <a:off x="868680" y="3520440"/>
+            <a:ext cx="3474720" cy="822960"/>
+          </a:xfrm>
+          <a:prstGeom prst="rect">
+            <a:avLst/>
+          </a:prstGeom>
+          <a:noFill/>
+          <a:ln/>
+        </p:spPr>
+        <p:txBody>
+          <a:bodyPr wrap="square" lIns="0" tIns="0" rIns="0" bIns="0" rtlCol="0" anchor="ctr"/>
+          <a:lstStyle/>
+          <a:p>
+            <a:pPr indent="0" marL="0">
+              <a:lnSpc>
+                <a:spcPct val="130000"/>
+              </a:lnSpc>
+              <a:buNone/>
+            </a:pPr>
+            <a:r>
+              <a:rPr lang="en-US" sz="1000" dirty="0">
+                <a:solidFill>
+                  <a:srgbClr val="374151"/>
                 </a:solidFill>
                 <a:latin typeface="Calibri" pitchFamily="34" charset="0"/>
                 <a:ea typeface="Calibri" pitchFamily="34" charset="-122"/>
                 <a:cs typeface="Calibri" pitchFamily="34" charset="-120"/>
               </a:rPr>
-              <a:t>consistent automated checks</a:t>
+              <a:t>GSTIN format validation, PAN-in-GSTIN cross-check. GST turnover vs bank credits variance flagging. Filing gap detection.</a:t>
             </a:r>
             <a:endParaRPr lang="en-US" sz="1000" dirty="0"/>
           </a:p>
@@ -3025,61 +3194,22 @@
       </p:sp>
       <p:sp>
         <p:nvSpPr>
-          <p:cNvPr id="17" name="Text 15"/>
-          <p:cNvSpPr/>
-          <p:nvPr/>
-        </p:nvSpPr>
-        <p:spPr>
-          <a:xfrm>
-            <a:off x="4846320" y="2377440"/>
-            <a:ext cx="1783080" cy="320040"/>
-          </a:xfrm>
-          <a:prstGeom prst="rect">
-            <a:avLst/>
-          </a:prstGeom>
-          <a:noFill/>
-          <a:ln/>
-        </p:spPr>
-        <p:txBody>
-          <a:bodyPr wrap="square" lIns="0" tIns="0" rIns="0" bIns="0" rtlCol="0" anchor="ctr"/>
-          <a:lstStyle/>
-          <a:p>
-            <a:pPr algn="ctr" indent="0" marL="0">
-              <a:buNone/>
-            </a:pPr>
-            <a:r>
-              <a:rPr lang="en-US" sz="900" dirty="0">
-                <a:solidFill>
-                  <a:srgbClr val="6B7280"/>
-                </a:solidFill>
-                <a:latin typeface="Calibri" pitchFamily="34" charset="0"/>
-                <a:ea typeface="Calibri" pitchFamily="34" charset="-122"/>
-                <a:cs typeface="Calibri" pitchFamily="34" charset="-120"/>
-              </a:rPr>
-              <a:t>dedupe, GSTIN, name match</a:t>
-            </a:r>
-            <a:endParaRPr lang="en-US" sz="900" dirty="0"/>
-          </a:p>
-        </p:txBody>
-      </p:sp>
-      <p:sp>
-        <p:nvSpPr>
           <p:cNvPr id="18" name="Shape 16"/>
           <p:cNvSpPr/>
           <p:nvPr/>
         </p:nvSpPr>
         <p:spPr>
           <a:xfrm>
-            <a:off x="6903720" y="1417320"/>
-            <a:ext cx="1965960" cy="1508760"/>
+            <a:off x="4754880" y="3063240"/>
+            <a:ext cx="3840480" cy="1417320"/>
           </a:xfrm>
           <a:prstGeom prst="roundRect">
             <a:avLst>
-              <a:gd name="adj" fmla="val 4848"/>
+              <a:gd name="adj" fmla="val 5161"/>
             </a:avLst>
           </a:prstGeom>
           <a:solidFill>
-            <a:srgbClr val="F4F5F7"/>
+            <a:srgbClr val="DCFCE7"/>
           </a:solidFill>
           <a:ln/>
           <a:effectLst>
@@ -3093,42 +3223,23 @@
       </p:sp>
       <p:sp>
         <p:nvSpPr>
-          <p:cNvPr id="19" name="Text 17"/>
-          <p:cNvSpPr/>
-          <p:nvPr/>
-        </p:nvSpPr>
-        <p:spPr>
-          <a:xfrm>
-            <a:off x="6903720" y="1508760"/>
-            <a:ext cx="1965960" cy="457200"/>
-          </a:xfrm>
-          <a:prstGeom prst="rect">
-            <a:avLst/>
-          </a:prstGeom>
-          <a:noFill/>
-          <a:ln/>
-        </p:spPr>
-        <p:txBody>
-          <a:bodyPr wrap="square" lIns="0" tIns="0" rIns="0" bIns="0" rtlCol="0" anchor="ctr"/>
-          <a:lstStyle/>
-          <a:p>
-            <a:pPr algn="ctr" indent="0" marL="0">
-              <a:buNone/>
-            </a:pPr>
-            <a:r>
-              <a:rPr lang="en-US" sz="2400" dirty="0">
-                <a:solidFill>
-                  <a:srgbClr val="3B82F6"/>
-                </a:solidFill>
-                <a:latin typeface="Arial Black" pitchFamily="34" charset="0"/>
-                <a:ea typeface="Arial Black" pitchFamily="34" charset="-122"/>
-                <a:cs typeface="Arial Black" pitchFamily="34" charset="-120"/>
-              </a:rPr>
-              <a:t>Linear</a:t>
-            </a:r>
-            <a:endParaRPr lang="en-US" sz="2400" dirty="0"/>
-          </a:p>
-        </p:txBody>
+          <p:cNvPr id="19" name="Shape 17"/>
+          <p:cNvSpPr/>
+          <p:nvPr/>
+        </p:nvSpPr>
+        <p:spPr>
+          <a:xfrm>
+            <a:off x="4754880" y="3063240"/>
+            <a:ext cx="73152" cy="1417320"/>
+          </a:xfrm>
+          <a:prstGeom prst="rect">
+            <a:avLst/>
+          </a:prstGeom>
+          <a:solidFill>
+            <a:srgbClr val="16A34A"/>
+          </a:solidFill>
+          <a:ln/>
+        </p:spPr>
       </p:sp>
       <p:sp>
         <p:nvSpPr>
@@ -3138,179 +3249,76 @@
         </p:nvSpPr>
         <p:spPr>
           <a:xfrm>
-            <a:off x="6995160" y="2011680"/>
-            <a:ext cx="1783080" cy="365760"/>
-          </a:xfrm>
-          <a:prstGeom prst="rect">
-            <a:avLst/>
-          </a:prstGeom>
-          <a:noFill/>
-          <a:ln/>
-        </p:spPr>
-        <p:txBody>
-          <a:bodyPr wrap="square" lIns="0" tIns="0" rIns="0" bIns="0" rtlCol="0" anchor="ctr"/>
-          <a:lstStyle/>
-          <a:p>
-            <a:pPr algn="ctr" indent="0" marL="0">
-              <a:buNone/>
-            </a:pPr>
-            <a:r>
-              <a:rPr lang="en-US" sz="1000" b="1" dirty="0">
+            <a:off x="4983480" y="3154680"/>
+            <a:ext cx="3474720" cy="274320"/>
+          </a:xfrm>
+          <a:prstGeom prst="rect">
+            <a:avLst/>
+          </a:prstGeom>
+          <a:noFill/>
+          <a:ln/>
+        </p:spPr>
+        <p:txBody>
+          <a:bodyPr wrap="square" lIns="0" tIns="0" rIns="0" bIns="0" rtlCol="0" anchor="ctr"/>
+          <a:lstStyle/>
+          <a:p>
+            <a:pPr indent="0" marL="0">
+              <a:buNone/>
+            </a:pPr>
+            <a:r>
+              <a:rPr lang="en-US" sz="1300" b="1" dirty="0">
                 <a:solidFill>
                   <a:srgbClr val="111827"/>
+                </a:solidFill>
+                <a:latin typeface="Arial" pitchFamily="34" charset="0"/>
+                <a:ea typeface="Arial" pitchFamily="34" charset="-122"/>
+                <a:cs typeface="Arial" pitchFamily="34" charset="-120"/>
+              </a:rPr>
+              <a:t>📋  Document Completeness</a:t>
+            </a:r>
+            <a:endParaRPr lang="en-US" sz="1300" dirty="0"/>
+          </a:p>
+        </p:txBody>
+      </p:sp>
+      <p:sp>
+        <p:nvSpPr>
+          <p:cNvPr id="21" name="Text 19"/>
+          <p:cNvSpPr/>
+          <p:nvPr/>
+        </p:nvSpPr>
+        <p:spPr>
+          <a:xfrm>
+            <a:off x="4983480" y="3520440"/>
+            <a:ext cx="3474720" cy="822960"/>
+          </a:xfrm>
+          <a:prstGeom prst="rect">
+            <a:avLst/>
+          </a:prstGeom>
+          <a:noFill/>
+          <a:ln/>
+        </p:spPr>
+        <p:txBody>
+          <a:bodyPr wrap="square" lIns="0" tIns="0" rIns="0" bIns="0" rtlCol="0" anchor="ctr"/>
+          <a:lstStyle/>
+          <a:p>
+            <a:pPr indent="0" marL="0">
+              <a:lnSpc>
+                <a:spcPct val="130000"/>
+              </a:lnSpc>
+              <a:buNone/>
+            </a:pPr>
+            <a:r>
+              <a:rPr lang="en-US" sz="1000" dirty="0">
+                <a:solidFill>
+                  <a:srgbClr val="374151"/>
                 </a:solidFill>
                 <a:latin typeface="Calibri" pitchFamily="34" charset="0"/>
                 <a:ea typeface="Calibri" pitchFamily="34" charset="-122"/>
                 <a:cs typeface="Calibri" pitchFamily="34" charset="-120"/>
               </a:rPr>
-              <a:t>scale without more analysts</a:t>
+              <a:t>Auto-checks if all required pre-PD documents are uploaded. Flags missing bank statements, GST returns, KYC, ITR before CM review starts.</a:t>
             </a:r>
             <a:endParaRPr lang="en-US" sz="1000" dirty="0"/>
-          </a:p>
-        </p:txBody>
-      </p:sp>
-      <p:sp>
-        <p:nvSpPr>
-          <p:cNvPr id="21" name="Text 19"/>
-          <p:cNvSpPr/>
-          <p:nvPr/>
-        </p:nvSpPr>
-        <p:spPr>
-          <a:xfrm>
-            <a:off x="6995160" y="2377440"/>
-            <a:ext cx="1783080" cy="320040"/>
-          </a:xfrm>
-          <a:prstGeom prst="rect">
-            <a:avLst/>
-          </a:prstGeom>
-          <a:noFill/>
-          <a:ln/>
-        </p:spPr>
-        <p:txBody>
-          <a:bodyPr wrap="square" lIns="0" tIns="0" rIns="0" bIns="0" rtlCol="0" anchor="ctr"/>
-          <a:lstStyle/>
-          <a:p>
-            <a:pPr algn="ctr" indent="0" marL="0">
-              <a:buNone/>
-            </a:pPr>
-            <a:r>
-              <a:rPr lang="en-US" sz="900" dirty="0">
-                <a:solidFill>
-                  <a:srgbClr val="6B7280"/>
-                </a:solidFill>
-                <a:latin typeface="Calibri" pitchFamily="34" charset="0"/>
-                <a:ea typeface="Calibri" pitchFamily="34" charset="-122"/>
-                <a:cs typeface="Calibri" pitchFamily="34" charset="-120"/>
-              </a:rPr>
-              <a:t>compounding learn-from-LLM</a:t>
-            </a:r>
-            <a:endParaRPr lang="en-US" sz="900" dirty="0"/>
-          </a:p>
-        </p:txBody>
-      </p:sp>
-      <p:sp>
-        <p:nvSpPr>
-          <p:cNvPr id="22" name="Text 20"/>
-          <p:cNvSpPr/>
-          <p:nvPr/>
-        </p:nvSpPr>
-        <p:spPr>
-          <a:xfrm>
-            <a:off x="640080" y="3200400"/>
-            <a:ext cx="7863840" cy="1645920"/>
-          </a:xfrm>
-          <a:prstGeom prst="rect">
-            <a:avLst/>
-          </a:prstGeom>
-          <a:noFill/>
-          <a:ln/>
-        </p:spPr>
-        <p:txBody>
-          <a:bodyPr wrap="square" lIns="0" tIns="0" rIns="0" bIns="0" rtlCol="0" anchor="ctr"/>
-          <a:lstStyle/>
-          <a:p>
-            <a:pPr marL="342900" indent="-342900">
-              <a:lnSpc>
-                <a:spcPct val="135000"/>
-              </a:lnSpc>
-              <a:buSzPct val="100000"/>
-              <a:buChar char="•"/>
-            </a:pPr>
-            <a:r>
-              <a:rPr lang="en-US" sz="1100" dirty="0">
-                <a:solidFill>
-                  <a:srgbClr val="374151"/>
-                </a:solidFill>
-                <a:latin typeface="Calibri" pitchFamily="34" charset="0"/>
-                <a:ea typeface="Calibri" pitchFamily="34" charset="-122"/>
-                <a:cs typeface="Calibri" pitchFamily="34" charset="-120"/>
-              </a:rPr>
-              <a:t>Removes manual updation — auto-populate, review exceptions only</a:t>
-            </a:r>
-            <a:endParaRPr lang="en-US" sz="1100" dirty="0"/>
-          </a:p>
-          <a:p>
-            <a:pPr marL="342900" indent="-342900">
-              <a:lnSpc>
-                <a:spcPct val="135000"/>
-              </a:lnSpc>
-              <a:buSzPct val="100000"/>
-              <a:buChar char="•"/>
-            </a:pPr>
-            <a:r>
-              <a:rPr lang="en-US" sz="1100" dirty="0">
-                <a:solidFill>
-                  <a:srgbClr val="374151"/>
-                </a:solidFill>
-                <a:latin typeface="Calibri" pitchFamily="34" charset="0"/>
-                <a:ea typeface="Calibri" pitchFamily="34" charset="-122"/>
-                <a:cs typeface="Calibri" pitchFamily="34" charset="-120"/>
-              </a:rPr>
-              <a:t>Cuts CE↔CM back-and-forth — completeness check flags missing docs upfront</a:t>
-            </a:r>
-            <a:endParaRPr lang="en-US" sz="1100" dirty="0"/>
-          </a:p>
-          <a:p>
-            <a:pPr marL="342900" indent="-342900">
-              <a:lnSpc>
-                <a:spcPct val="135000"/>
-              </a:lnSpc>
-              <a:buSzPct val="100000"/>
-              <a:buChar char="•"/>
-            </a:pPr>
-            <a:r>
-              <a:rPr lang="en-US" sz="1100" dirty="0">
-                <a:solidFill>
-                  <a:srgbClr val="374151"/>
-                </a:solidFill>
-                <a:latin typeface="Calibri" pitchFamily="34" charset="0"/>
-                <a:ea typeface="Calibri" pitchFamily="34" charset="-122"/>
-                <a:cs typeface="Calibri" pitchFamily="34" charset="-120"/>
-              </a:rPr>
-              <a:t>Compounding returns — each new bank format is a one-time cost, then pure rules</a:t>
-            </a:r>
-            <a:endParaRPr lang="en-US" sz="1100" dirty="0"/>
-          </a:p>
-          <a:p>
-            <a:pPr marL="342900" indent="-342900">
-              <a:lnSpc>
-                <a:spcPct val="135000"/>
-              </a:lnSpc>
-              <a:buSzPct val="100000"/>
-              <a:buChar char="•"/>
-            </a:pPr>
-            <a:r>
-              <a:rPr lang="en-US" sz="1100" dirty="0">
-                <a:solidFill>
-                  <a:srgbClr val="374151"/>
-                </a:solidFill>
-                <a:latin typeface="Calibri" pitchFamily="34" charset="0"/>
-                <a:ea typeface="Calibri" pitchFamily="34" charset="-122"/>
-                <a:cs typeface="Calibri" pitchFamily="34" charset="-120"/>
-              </a:rPr>
-              <a:t>Scales linearly — more applications ≠ proportionally more analyst hours</a:t>
-            </a:r>
-            <a:endParaRPr lang="en-US" sz="1100" dirty="0"/>
           </a:p>
         </p:txBody>
       </p:sp>
@@ -3325,6 +3333,778 @@
 <file path=ppt/slides/slide12.xml><?xml version="1.0" encoding="utf-8"?>
 <p:sld xmlns:a="http://schemas.openxmlformats.org/drawingml/2006/main" xmlns:r="http://schemas.openxmlformats.org/officeDocument/2006/relationships" xmlns:p="http://schemas.openxmlformats.org/presentationml/2006/main">
   <p:cSld name="Slide 12">
+    <p:bg>
+      <p:bgPr>
+        <a:solidFill>
+          <a:srgbClr val="1E2761"/>
+        </a:solidFill>
+      </p:bgPr>
+    </p:bg>
+    <p:spTree>
+      <p:nvGrpSpPr>
+        <p:cNvPr id="1" name=""/>
+        <p:cNvGrpSpPr/>
+        <p:nvPr/>
+      </p:nvGrpSpPr>
+      <p:grpSpPr>
+        <a:xfrm>
+          <a:off x="0" y="0"/>
+          <a:ext cx="0" cy="0"/>
+          <a:chOff x="0" y="0"/>
+          <a:chExt cx="0" cy="0"/>
+        </a:xfrm>
+      </p:grpSpPr>
+      <p:sp>
+        <p:nvSpPr>
+          <p:cNvPr id="2" name="Text 0"/>
+          <p:cNvSpPr/>
+          <p:nvPr/>
+        </p:nvSpPr>
+        <p:spPr>
+          <a:xfrm>
+            <a:off x="640080" y="320040"/>
+            <a:ext cx="7863840" cy="502920"/>
+          </a:xfrm>
+          <a:prstGeom prst="rect">
+            <a:avLst/>
+          </a:prstGeom>
+          <a:noFill/>
+          <a:ln/>
+        </p:spPr>
+        <p:txBody>
+          <a:bodyPr wrap="square" lIns="0" tIns="0" rIns="0" bIns="0" rtlCol="0" anchor="ctr"/>
+          <a:lstStyle/>
+          <a:p>
+            <a:pPr indent="0" marL="0">
+              <a:buNone/>
+            </a:pPr>
+            <a:r>
+              <a:rPr lang="en-US" sz="2800" b="1" dirty="0">
+                <a:solidFill>
+                  <a:srgbClr val="FFFFFF"/>
+                </a:solidFill>
+                <a:latin typeface="Arial Black" pitchFamily="34" charset="0"/>
+                <a:ea typeface="Arial Black" pitchFamily="34" charset="-122"/>
+                <a:cs typeface="Arial Black" pitchFamily="34" charset="-120"/>
+              </a:rPr>
+              <a:t>Fraud Portal: Attention Panel</a:t>
+            </a:r>
+            <a:endParaRPr lang="en-US" sz="2800" dirty="0"/>
+          </a:p>
+        </p:txBody>
+      </p:sp>
+      <p:sp>
+        <p:nvSpPr>
+          <p:cNvPr id="3" name="Text 1"/>
+          <p:cNvSpPr/>
+          <p:nvPr/>
+        </p:nvSpPr>
+        <p:spPr>
+          <a:xfrm>
+            <a:off x="640080" y="868680"/>
+            <a:ext cx="7863840" cy="365760"/>
+          </a:xfrm>
+          <a:prstGeom prst="rect">
+            <a:avLst/>
+          </a:prstGeom>
+          <a:noFill/>
+          <a:ln/>
+        </p:spPr>
+        <p:txBody>
+          <a:bodyPr wrap="square" lIns="0" tIns="0" rIns="0" bIns="0" rtlCol="0" anchor="ctr"/>
+          <a:lstStyle/>
+          <a:p>
+            <a:pPr indent="0" marL="0">
+              <a:buNone/>
+            </a:pPr>
+            <a:r>
+              <a:rPr lang="en-US" sz="1300" i="1" dirty="0">
+                <a:solidFill>
+                  <a:srgbClr val="CADCFC"/>
+                </a:solidFill>
+                <a:latin typeface="Calibri" pitchFamily="34" charset="0"/>
+                <a:ea typeface="Calibri" pitchFamily="34" charset="-122"/>
+                <a:cs typeface="Calibri" pitchFamily="34" charset="-120"/>
+              </a:rPr>
+              <a:t>Every exception surfaces as a finding — severity-ranked, evidence-linked, auditable</a:t>
+            </a:r>
+            <a:endParaRPr lang="en-US" sz="1300" dirty="0"/>
+          </a:p>
+        </p:txBody>
+      </p:sp>
+      <p:sp>
+        <p:nvSpPr>
+          <p:cNvPr id="4" name="Text 2"/>
+          <p:cNvSpPr/>
+          <p:nvPr/>
+        </p:nvSpPr>
+        <p:spPr>
+          <a:xfrm>
+            <a:off x="8503920" y="4800600"/>
+            <a:ext cx="457200" cy="274320"/>
+          </a:xfrm>
+          <a:prstGeom prst="rect">
+            <a:avLst/>
+          </a:prstGeom>
+          <a:noFill/>
+          <a:ln/>
+        </p:spPr>
+        <p:txBody>
+          <a:bodyPr wrap="square" lIns="0" tIns="0" rIns="0" bIns="0" rtlCol="0" anchor="ctr"/>
+          <a:lstStyle/>
+          <a:p>
+            <a:pPr algn="r" indent="0" marL="0">
+              <a:buNone/>
+            </a:pPr>
+            <a:r>
+              <a:rPr lang="en-US" sz="900" dirty="0">
+                <a:solidFill>
+                  <a:srgbClr val="6B7280"/>
+                </a:solidFill>
+                <a:latin typeface="Calibri" pitchFamily="34" charset="0"/>
+                <a:ea typeface="Calibri" pitchFamily="34" charset="-122"/>
+                <a:cs typeface="Calibri" pitchFamily="34" charset="-120"/>
+              </a:rPr>
+              <a:t>12</a:t>
+            </a:r>
+            <a:endParaRPr lang="en-US" sz="900" dirty="0"/>
+          </a:p>
+        </p:txBody>
+      </p:sp>
+      <p:sp>
+        <p:nvSpPr>
+          <p:cNvPr id="5" name="Shape 3"/>
+          <p:cNvSpPr/>
+          <p:nvPr/>
+        </p:nvSpPr>
+        <p:spPr>
+          <a:xfrm>
+            <a:off x="731520" y="1463040"/>
+            <a:ext cx="2560320" cy="2011680"/>
+          </a:xfrm>
+          <a:prstGeom prst="roundRect">
+            <a:avLst>
+              <a:gd name="adj" fmla="val 3636"/>
+            </a:avLst>
+          </a:prstGeom>
+          <a:solidFill>
+            <a:srgbClr val="3D1010"/>
+          </a:solidFill>
+          <a:ln/>
+          <a:effectLst>
+            <a:outerShdw sx="100000" sy="100000" kx="0" ky="0" algn="bl" rotWithShape="0" blurRad="50800" dist="12700" dir="8100000">
+              <a:srgbClr val="000000">
+                <a:alpha val="8000"/>
+              </a:srgbClr>
+            </a:outerShdw>
+          </a:effectLst>
+        </p:spPr>
+      </p:sp>
+      <p:sp>
+        <p:nvSpPr>
+          <p:cNvPr id="6" name="Shape 4"/>
+          <p:cNvSpPr/>
+          <p:nvPr/>
+        </p:nvSpPr>
+        <p:spPr>
+          <a:xfrm>
+            <a:off x="822960" y="1572768"/>
+            <a:ext cx="640080" cy="274320"/>
+          </a:xfrm>
+          <a:prstGeom prst="roundRect">
+            <a:avLst>
+              <a:gd name="adj" fmla="val 16667"/>
+            </a:avLst>
+          </a:prstGeom>
+          <a:solidFill>
+            <a:srgbClr val="DC2626"/>
+          </a:solidFill>
+          <a:ln/>
+        </p:spPr>
+      </p:sp>
+      <p:sp>
+        <p:nvSpPr>
+          <p:cNvPr id="7" name="Text 5"/>
+          <p:cNvSpPr/>
+          <p:nvPr/>
+        </p:nvSpPr>
+        <p:spPr>
+          <a:xfrm>
+            <a:off x="822960" y="1572768"/>
+            <a:ext cx="640080" cy="274320"/>
+          </a:xfrm>
+          <a:prstGeom prst="rect">
+            <a:avLst/>
+          </a:prstGeom>
+          <a:noFill/>
+          <a:ln/>
+        </p:spPr>
+        <p:txBody>
+          <a:bodyPr wrap="square" lIns="0" tIns="0" rIns="0" bIns="0" rtlCol="0" anchor="ctr"/>
+          <a:lstStyle/>
+          <a:p>
+            <a:pPr algn="ctr" indent="0" marL="0">
+              <a:buNone/>
+            </a:pPr>
+            <a:r>
+              <a:rPr lang="en-US" sz="900" b="1" dirty="0">
+                <a:solidFill>
+                  <a:srgbClr val="FFFFFF"/>
+                </a:solidFill>
+                <a:latin typeface="Arial" pitchFamily="34" charset="0"/>
+                <a:ea typeface="Arial" pitchFamily="34" charset="-122"/>
+                <a:cs typeface="Arial" pitchFamily="34" charset="-120"/>
+              </a:rPr>
+              <a:t>HIGH</a:t>
+            </a:r>
+            <a:endParaRPr lang="en-US" sz="900" dirty="0"/>
+          </a:p>
+        </p:txBody>
+      </p:sp>
+      <p:sp>
+        <p:nvSpPr>
+          <p:cNvPr id="8" name="Text 6"/>
+          <p:cNvSpPr/>
+          <p:nvPr/>
+        </p:nvSpPr>
+        <p:spPr>
+          <a:xfrm>
+            <a:off x="868680" y="1965960"/>
+            <a:ext cx="2286000" cy="1280160"/>
+          </a:xfrm>
+          <a:prstGeom prst="rect">
+            <a:avLst/>
+          </a:prstGeom>
+          <a:noFill/>
+          <a:ln/>
+        </p:spPr>
+        <p:txBody>
+          <a:bodyPr wrap="square" lIns="0" tIns="0" rIns="0" bIns="0" rtlCol="0" anchor="ctr"/>
+          <a:lstStyle/>
+          <a:p>
+            <a:pPr indent="0" marL="0">
+              <a:lnSpc>
+                <a:spcPct val="140000"/>
+              </a:lnSpc>
+              <a:buNone/>
+            </a:pPr>
+            <a:r>
+              <a:rPr lang="en-US" sz="1000" dirty="0">
+                <a:solidFill>
+                  <a:srgbClr val="CADCFC"/>
+                </a:solidFill>
+                <a:latin typeface="Calibri" pitchFamily="34" charset="0"/>
+                <a:ea typeface="Calibri" pitchFamily="34" charset="-122"/>
+                <a:cs typeface="Calibri" pitchFamily="34" charset="-120"/>
+              </a:rPr>
+              <a:t>Tampered bank statement</a:t>
+            </a:r>
+            <a:endParaRPr lang="en-US" sz="1000" dirty="0"/>
+          </a:p>
+          <a:p>
+            <a:pPr indent="0" marL="0">
+              <a:lnSpc>
+                <a:spcPct val="140000"/>
+              </a:lnSpc>
+              <a:buNone/>
+            </a:pPr>
+            <a:r>
+              <a:rPr lang="en-US" sz="1000" dirty="0">
+                <a:solidFill>
+                  <a:srgbClr val="CADCFC"/>
+                </a:solidFill>
+                <a:latin typeface="Calibri" pitchFamily="34" charset="0"/>
+                <a:ea typeface="Calibri" pitchFamily="34" charset="-122"/>
+                <a:cs typeface="Calibri" pitchFamily="34" charset="-120"/>
+              </a:rPr>
+              <a:t>PAN dedupe clash</a:t>
+            </a:r>
+            <a:endParaRPr lang="en-US" sz="1000" dirty="0"/>
+          </a:p>
+          <a:p>
+            <a:pPr indent="0" marL="0">
+              <a:lnSpc>
+                <a:spcPct val="140000"/>
+              </a:lnSpc>
+              <a:buNone/>
+            </a:pPr>
+            <a:r>
+              <a:rPr lang="en-US" sz="1000" dirty="0">
+                <a:solidFill>
+                  <a:srgbClr val="CADCFC"/>
+                </a:solidFill>
+                <a:latin typeface="Calibri" pitchFamily="34" charset="0"/>
+                <a:ea typeface="Calibri" pitchFamily="34" charset="-122"/>
+                <a:cs typeface="Calibri" pitchFamily="34" charset="-120"/>
+              </a:rPr>
+              <a:t>GSTIN-PAN mismatch</a:t>
+            </a:r>
+            <a:endParaRPr lang="en-US" sz="1000" dirty="0"/>
+          </a:p>
+        </p:txBody>
+      </p:sp>
+      <p:sp>
+        <p:nvSpPr>
+          <p:cNvPr id="9" name="Shape 7"/>
+          <p:cNvSpPr/>
+          <p:nvPr/>
+        </p:nvSpPr>
+        <p:spPr>
+          <a:xfrm>
+            <a:off x="3566160" y="1463040"/>
+            <a:ext cx="2560320" cy="2011680"/>
+          </a:xfrm>
+          <a:prstGeom prst="roundRect">
+            <a:avLst>
+              <a:gd name="adj" fmla="val 3636"/>
+            </a:avLst>
+          </a:prstGeom>
+          <a:solidFill>
+            <a:srgbClr val="3D3306"/>
+          </a:solidFill>
+          <a:ln/>
+          <a:effectLst>
+            <a:outerShdw sx="100000" sy="100000" kx="0" ky="0" algn="bl" rotWithShape="0" blurRad="50800" dist="12700" dir="8100000">
+              <a:srgbClr val="000000">
+                <a:alpha val="8000"/>
+              </a:srgbClr>
+            </a:outerShdw>
+          </a:effectLst>
+        </p:spPr>
+      </p:sp>
+      <p:sp>
+        <p:nvSpPr>
+          <p:cNvPr id="10" name="Shape 8"/>
+          <p:cNvSpPr/>
+          <p:nvPr/>
+        </p:nvSpPr>
+        <p:spPr>
+          <a:xfrm>
+            <a:off x="3657600" y="1572768"/>
+            <a:ext cx="640080" cy="274320"/>
+          </a:xfrm>
+          <a:prstGeom prst="roundRect">
+            <a:avLst>
+              <a:gd name="adj" fmla="val 16667"/>
+            </a:avLst>
+          </a:prstGeom>
+          <a:solidFill>
+            <a:srgbClr val="F59E0B"/>
+          </a:solidFill>
+          <a:ln/>
+        </p:spPr>
+      </p:sp>
+      <p:sp>
+        <p:nvSpPr>
+          <p:cNvPr id="11" name="Text 9"/>
+          <p:cNvSpPr/>
+          <p:nvPr/>
+        </p:nvSpPr>
+        <p:spPr>
+          <a:xfrm>
+            <a:off x="3657600" y="1572768"/>
+            <a:ext cx="640080" cy="274320"/>
+          </a:xfrm>
+          <a:prstGeom prst="rect">
+            <a:avLst/>
+          </a:prstGeom>
+          <a:noFill/>
+          <a:ln/>
+        </p:spPr>
+        <p:txBody>
+          <a:bodyPr wrap="square" lIns="0" tIns="0" rIns="0" bIns="0" rtlCol="0" anchor="ctr"/>
+          <a:lstStyle/>
+          <a:p>
+            <a:pPr algn="ctr" indent="0" marL="0">
+              <a:buNone/>
+            </a:pPr>
+            <a:r>
+              <a:rPr lang="en-US" sz="900" b="1" dirty="0">
+                <a:solidFill>
+                  <a:srgbClr val="FFFFFF"/>
+                </a:solidFill>
+                <a:latin typeface="Arial" pitchFamily="34" charset="0"/>
+                <a:ea typeface="Arial" pitchFamily="34" charset="-122"/>
+                <a:cs typeface="Arial" pitchFamily="34" charset="-120"/>
+              </a:rPr>
+              <a:t>MEDIUM</a:t>
+            </a:r>
+            <a:endParaRPr lang="en-US" sz="900" dirty="0"/>
+          </a:p>
+        </p:txBody>
+      </p:sp>
+      <p:sp>
+        <p:nvSpPr>
+          <p:cNvPr id="12" name="Text 10"/>
+          <p:cNvSpPr/>
+          <p:nvPr/>
+        </p:nvSpPr>
+        <p:spPr>
+          <a:xfrm>
+            <a:off x="3703320" y="1965960"/>
+            <a:ext cx="2286000" cy="1280160"/>
+          </a:xfrm>
+          <a:prstGeom prst="rect">
+            <a:avLst/>
+          </a:prstGeom>
+          <a:noFill/>
+          <a:ln/>
+        </p:spPr>
+        <p:txBody>
+          <a:bodyPr wrap="square" lIns="0" tIns="0" rIns="0" bIns="0" rtlCol="0" anchor="ctr"/>
+          <a:lstStyle/>
+          <a:p>
+            <a:pPr indent="0" marL="0">
+              <a:lnSpc>
+                <a:spcPct val="140000"/>
+              </a:lnSpc>
+              <a:buNone/>
+            </a:pPr>
+            <a:r>
+              <a:rPr lang="en-US" sz="1000" dirty="0">
+                <a:solidFill>
+                  <a:srgbClr val="CADCFC"/>
+                </a:solidFill>
+                <a:latin typeface="Calibri" pitchFamily="34" charset="0"/>
+                <a:ea typeface="Calibri" pitchFamily="34" charset="-122"/>
+                <a:cs typeface="Calibri" pitchFamily="34" charset="-120"/>
+              </a:rPr>
+              <a:t>Name mismatch on bank stmt</a:t>
+            </a:r>
+            <a:endParaRPr lang="en-US" sz="1000" dirty="0"/>
+          </a:p>
+          <a:p>
+            <a:pPr indent="0" marL="0">
+              <a:lnSpc>
+                <a:spcPct val="140000"/>
+              </a:lnSpc>
+              <a:buNone/>
+            </a:pPr>
+            <a:r>
+              <a:rPr lang="en-US" sz="1000" dirty="0">
+                <a:solidFill>
+                  <a:srgbClr val="CADCFC"/>
+                </a:solidFill>
+                <a:latin typeface="Calibri" pitchFamily="34" charset="0"/>
+                <a:ea typeface="Calibri" pitchFamily="34" charset="-122"/>
+                <a:cs typeface="Calibri" pitchFamily="34" charset="-120"/>
+              </a:rPr>
+              <a:t>Mobile dedupe clash</a:t>
+            </a:r>
+            <a:endParaRPr lang="en-US" sz="1000" dirty="0"/>
+          </a:p>
+          <a:p>
+            <a:pPr indent="0" marL="0">
+              <a:lnSpc>
+                <a:spcPct val="140000"/>
+              </a:lnSpc>
+              <a:buNone/>
+            </a:pPr>
+            <a:r>
+              <a:rPr lang="en-US" sz="1000" dirty="0">
+                <a:solidFill>
+                  <a:srgbClr val="CADCFC"/>
+                </a:solidFill>
+                <a:latin typeface="Calibri" pitchFamily="34" charset="0"/>
+                <a:ea typeface="Calibri" pitchFamily="34" charset="-122"/>
+                <a:cs typeface="Calibri" pitchFamily="34" charset="-120"/>
+              </a:rPr>
+              <a:t>GSTIN format invalid</a:t>
+            </a:r>
+            <a:endParaRPr lang="en-US" sz="1000" dirty="0"/>
+          </a:p>
+        </p:txBody>
+      </p:sp>
+      <p:sp>
+        <p:nvSpPr>
+          <p:cNvPr id="13" name="Shape 11"/>
+          <p:cNvSpPr/>
+          <p:nvPr/>
+        </p:nvSpPr>
+        <p:spPr>
+          <a:xfrm>
+            <a:off x="6400800" y="1463040"/>
+            <a:ext cx="2560320" cy="2011680"/>
+          </a:xfrm>
+          <a:prstGeom prst="roundRect">
+            <a:avLst>
+              <a:gd name="adj" fmla="val 3636"/>
+            </a:avLst>
+          </a:prstGeom>
+          <a:solidFill>
+            <a:srgbClr val="0F1A3D"/>
+          </a:solidFill>
+          <a:ln/>
+          <a:effectLst>
+            <a:outerShdw sx="100000" sy="100000" kx="0" ky="0" algn="bl" rotWithShape="0" blurRad="50800" dist="12700" dir="8100000">
+              <a:srgbClr val="000000">
+                <a:alpha val="8000"/>
+              </a:srgbClr>
+            </a:outerShdw>
+          </a:effectLst>
+        </p:spPr>
+      </p:sp>
+      <p:sp>
+        <p:nvSpPr>
+          <p:cNvPr id="14" name="Shape 12"/>
+          <p:cNvSpPr/>
+          <p:nvPr/>
+        </p:nvSpPr>
+        <p:spPr>
+          <a:xfrm>
+            <a:off x="6492240" y="1572768"/>
+            <a:ext cx="640080" cy="274320"/>
+          </a:xfrm>
+          <a:prstGeom prst="roundRect">
+            <a:avLst>
+              <a:gd name="adj" fmla="val 16667"/>
+            </a:avLst>
+          </a:prstGeom>
+          <a:solidFill>
+            <a:srgbClr val="3B82F6"/>
+          </a:solidFill>
+          <a:ln/>
+        </p:spPr>
+      </p:sp>
+      <p:sp>
+        <p:nvSpPr>
+          <p:cNvPr id="15" name="Text 13"/>
+          <p:cNvSpPr/>
+          <p:nvPr/>
+        </p:nvSpPr>
+        <p:spPr>
+          <a:xfrm>
+            <a:off x="6492240" y="1572768"/>
+            <a:ext cx="640080" cy="274320"/>
+          </a:xfrm>
+          <a:prstGeom prst="rect">
+            <a:avLst/>
+          </a:prstGeom>
+          <a:noFill/>
+          <a:ln/>
+        </p:spPr>
+        <p:txBody>
+          <a:bodyPr wrap="square" lIns="0" tIns="0" rIns="0" bIns="0" rtlCol="0" anchor="ctr"/>
+          <a:lstStyle/>
+          <a:p>
+            <a:pPr algn="ctr" indent="0" marL="0">
+              <a:buNone/>
+            </a:pPr>
+            <a:r>
+              <a:rPr lang="en-US" sz="900" b="1" dirty="0">
+                <a:solidFill>
+                  <a:srgbClr val="FFFFFF"/>
+                </a:solidFill>
+                <a:latin typeface="Arial" pitchFamily="34" charset="0"/>
+                <a:ea typeface="Arial" pitchFamily="34" charset="-122"/>
+                <a:cs typeface="Arial" pitchFamily="34" charset="-120"/>
+              </a:rPr>
+              <a:t>LOW</a:t>
+            </a:r>
+            <a:endParaRPr lang="en-US" sz="900" dirty="0"/>
+          </a:p>
+        </p:txBody>
+      </p:sp>
+      <p:sp>
+        <p:nvSpPr>
+          <p:cNvPr id="16" name="Text 14"/>
+          <p:cNvSpPr/>
+          <p:nvPr/>
+        </p:nvSpPr>
+        <p:spPr>
+          <a:xfrm>
+            <a:off x="6537960" y="1965960"/>
+            <a:ext cx="2286000" cy="1280160"/>
+          </a:xfrm>
+          <a:prstGeom prst="rect">
+            <a:avLst/>
+          </a:prstGeom>
+          <a:noFill/>
+          <a:ln/>
+        </p:spPr>
+        <p:txBody>
+          <a:bodyPr wrap="square" lIns="0" tIns="0" rIns="0" bIns="0" rtlCol="0" anchor="ctr"/>
+          <a:lstStyle/>
+          <a:p>
+            <a:pPr indent="0" marL="0">
+              <a:lnSpc>
+                <a:spcPct val="140000"/>
+              </a:lnSpc>
+              <a:buNone/>
+            </a:pPr>
+            <a:r>
+              <a:rPr lang="en-US" sz="1000" dirty="0">
+                <a:solidFill>
+                  <a:srgbClr val="CADCFC"/>
+                </a:solidFill>
+                <a:latin typeface="Calibri" pitchFamily="34" charset="0"/>
+                <a:ea typeface="Calibri" pitchFamily="34" charset="-122"/>
+                <a:cs typeface="Calibri" pitchFamily="34" charset="-120"/>
+              </a:rPr>
+              <a:t>Minor GST variance</a:t>
+            </a:r>
+            <a:endParaRPr lang="en-US" sz="1000" dirty="0"/>
+          </a:p>
+          <a:p>
+            <a:pPr indent="0" marL="0">
+              <a:lnSpc>
+                <a:spcPct val="140000"/>
+              </a:lnSpc>
+              <a:buNone/>
+            </a:pPr>
+            <a:r>
+              <a:rPr lang="en-US" sz="1000" dirty="0">
+                <a:solidFill>
+                  <a:srgbClr val="CADCFC"/>
+                </a:solidFill>
+                <a:latin typeface="Calibri" pitchFamily="34" charset="0"/>
+                <a:ea typeface="Calibri" pitchFamily="34" charset="-122"/>
+                <a:cs typeface="Calibri" pitchFamily="34" charset="-120"/>
+              </a:rPr>
+              <a:t>Document completeness gap</a:t>
+            </a:r>
+            <a:endParaRPr lang="en-US" sz="1000" dirty="0"/>
+          </a:p>
+          <a:p>
+            <a:pPr indent="0" marL="0">
+              <a:lnSpc>
+                <a:spcPct val="140000"/>
+              </a:lnSpc>
+              <a:buNone/>
+            </a:pPr>
+            <a:r>
+              <a:rPr lang="en-US" sz="1000" dirty="0">
+                <a:solidFill>
+                  <a:srgbClr val="CADCFC"/>
+                </a:solidFill>
+                <a:latin typeface="Calibri" pitchFamily="34" charset="0"/>
+                <a:ea typeface="Calibri" pitchFamily="34" charset="-122"/>
+                <a:cs typeface="Calibri" pitchFamily="34" charset="-120"/>
+              </a:rPr>
+              <a:t>Filing frequency irregular</a:t>
+            </a:r>
+            <a:endParaRPr lang="en-US" sz="1000" dirty="0"/>
+          </a:p>
+        </p:txBody>
+      </p:sp>
+      <p:sp>
+        <p:nvSpPr>
+          <p:cNvPr id="17" name="Shape 15"/>
+          <p:cNvSpPr/>
+          <p:nvPr/>
+        </p:nvSpPr>
+        <p:spPr>
+          <a:xfrm>
+            <a:off x="731520" y="3749040"/>
+            <a:ext cx="7680960" cy="914400"/>
+          </a:xfrm>
+          <a:prstGeom prst="roundRect">
+            <a:avLst>
+              <a:gd name="adj" fmla="val 8000"/>
+            </a:avLst>
+          </a:prstGeom>
+          <a:solidFill>
+            <a:srgbClr val="1A2040"/>
+          </a:solidFill>
+          <a:ln/>
+          <a:effectLst>
+            <a:outerShdw sx="100000" sy="100000" kx="0" ky="0" algn="bl" rotWithShape="0" blurRad="50800" dist="12700" dir="8100000">
+              <a:srgbClr val="000000">
+                <a:alpha val="8000"/>
+              </a:srgbClr>
+            </a:outerShdw>
+          </a:effectLst>
+        </p:spPr>
+      </p:sp>
+      <p:sp>
+        <p:nvSpPr>
+          <p:cNvPr id="18" name="Text 16"/>
+          <p:cNvSpPr/>
+          <p:nvPr/>
+        </p:nvSpPr>
+        <p:spPr>
+          <a:xfrm>
+            <a:off x="914400" y="3822192"/>
+            <a:ext cx="2743200" cy="228600"/>
+          </a:xfrm>
+          <a:prstGeom prst="rect">
+            <a:avLst/>
+          </a:prstGeom>
+          <a:noFill/>
+          <a:ln/>
+        </p:spPr>
+        <p:txBody>
+          <a:bodyPr wrap="square" lIns="0" tIns="0" rIns="0" bIns="0" rtlCol="0" anchor="ctr"/>
+          <a:lstStyle/>
+          <a:p>
+            <a:pPr indent="0" marL="0">
+              <a:buNone/>
+            </a:pPr>
+            <a:r>
+              <a:rPr lang="en-US" sz="1100" b="1" dirty="0">
+                <a:solidFill>
+                  <a:srgbClr val="3B82F6"/>
+                </a:solidFill>
+                <a:latin typeface="Arial" pitchFamily="34" charset="0"/>
+                <a:ea typeface="Arial" pitchFamily="34" charset="-122"/>
+                <a:cs typeface="Arial" pitchFamily="34" charset="-120"/>
+              </a:rPr>
+              <a:t>Each finding is structured:</a:t>
+            </a:r>
+            <a:endParaRPr lang="en-US" sz="1100" dirty="0"/>
+          </a:p>
+        </p:txBody>
+      </p:sp>
+      <p:sp>
+        <p:nvSpPr>
+          <p:cNvPr id="19" name="Text 17"/>
+          <p:cNvSpPr/>
+          <p:nvPr/>
+        </p:nvSpPr>
+        <p:spPr>
+          <a:xfrm>
+            <a:off x="914400" y="4114800"/>
+            <a:ext cx="7315200" cy="411480"/>
+          </a:xfrm>
+          <a:prstGeom prst="rect">
+            <a:avLst/>
+          </a:prstGeom>
+          <a:noFill/>
+          <a:ln/>
+        </p:spPr>
+        <p:txBody>
+          <a:bodyPr wrap="square" lIns="0" tIns="0" rIns="0" bIns="0" rtlCol="0" anchor="ctr"/>
+          <a:lstStyle/>
+          <a:p>
+            <a:pPr indent="0" marL="0">
+              <a:buNone/>
+            </a:pPr>
+            <a:r>
+              <a:rPr lang="en-US" sz="900" dirty="0">
+                <a:solidFill>
+                  <a:srgbClr val="CADCFC"/>
+                </a:solidFill>
+                <a:latin typeface="Consolas" pitchFamily="34" charset="0"/>
+                <a:ea typeface="Consolas" pitchFamily="34" charset="-122"/>
+                <a:cs typeface="Consolas" pitchFamily="34" charset="-120"/>
+              </a:rPr>
+              <a:t>{ "doc": "bank_statement.pdf", "type": "tampered_total", "severity": "high", "evidence": "Font mismatch on total row", "confidence": 0.81 }</a:t>
+            </a:r>
+            <a:endParaRPr lang="en-US" sz="900" dirty="0"/>
+          </a:p>
+        </p:txBody>
+      </p:sp>
+    </p:spTree>
+  </p:cSld>
+  <p:clrMapOvr>
+    <a:masterClrMapping/>
+  </p:clrMapOvr>
+</p:sld>
+</file>
+
+<file path=ppt/slides/slide13.xml><?xml version="1.0" encoding="utf-8"?>
+<p:sld xmlns:a="http://schemas.openxmlformats.org/drawingml/2006/main" xmlns:r="http://schemas.openxmlformats.org/officeDocument/2006/relationships" xmlns:p="http://schemas.openxmlformats.org/presentationml/2006/main">
+  <p:cSld name="Slide 13">
     <p:bg>
       <p:bgPr>
         <a:solidFill>
@@ -3399,7 +4179,7 @@
                 <a:ea typeface="Arial Black" pitchFamily="34" charset="-122"/>
                 <a:cs typeface="Arial Black" pitchFamily="34" charset="-120"/>
               </a:rPr>
-              <a:t>Roadmap &amp; Ask</a:t>
+              <a:t>Business Impact</a:t>
             </a:r>
             <a:endParaRPr lang="en-US" sz="2800" dirty="0"/>
           </a:p>
@@ -3413,24 +4193,24 @@
         </p:nvSpPr>
         <p:spPr>
           <a:xfrm>
-            <a:off x="8503920" y="4800600"/>
-            <a:ext cx="457200" cy="274320"/>
-          </a:xfrm>
-          <a:prstGeom prst="rect">
-            <a:avLst/>
-          </a:prstGeom>
-          <a:noFill/>
-          <a:ln/>
-        </p:spPr>
-        <p:txBody>
-          <a:bodyPr wrap="square" lIns="0" tIns="0" rIns="0" bIns="0" rtlCol="0" anchor="ctr"/>
-          <a:lstStyle/>
-          <a:p>
-            <a:pPr algn="r" indent="0" marL="0">
-              <a:buNone/>
-            </a:pPr>
-            <a:r>
-              <a:rPr lang="en-US" sz="900" dirty="0">
+            <a:off x="640080" y="868680"/>
+            <a:ext cx="7863840" cy="365760"/>
+          </a:xfrm>
+          <a:prstGeom prst="rect">
+            <a:avLst/>
+          </a:prstGeom>
+          <a:noFill/>
+          <a:ln/>
+        </p:spPr>
+        <p:txBody>
+          <a:bodyPr wrap="square" lIns="0" tIns="0" rIns="0" bIns="0" rtlCol="0" anchor="ctr"/>
+          <a:lstStyle/>
+          <a:p>
+            <a:pPr indent="0" marL="0">
+              <a:buNone/>
+            </a:pPr>
+            <a:r>
+              <a:rPr lang="en-US" sz="1300" i="1" dirty="0">
                 <a:solidFill>
                   <a:srgbClr val="6B7280"/>
                 </a:solidFill>
@@ -3438,7 +4218,46 @@
                 <a:ea typeface="Calibri" pitchFamily="34" charset="-122"/>
                 <a:cs typeface="Calibri" pitchFamily="34" charset="-120"/>
               </a:rPr>
-              <a:t>12</a:t>
+              <a:t>Primary lever: underwriter bandwidth → operations cost</a:t>
+            </a:r>
+            <a:endParaRPr lang="en-US" sz="1300" dirty="0"/>
+          </a:p>
+        </p:txBody>
+      </p:sp>
+      <p:sp>
+        <p:nvSpPr>
+          <p:cNvPr id="5" name="Text 3"/>
+          <p:cNvSpPr/>
+          <p:nvPr/>
+        </p:nvSpPr>
+        <p:spPr>
+          <a:xfrm>
+            <a:off x="8503920" y="4800600"/>
+            <a:ext cx="457200" cy="274320"/>
+          </a:xfrm>
+          <a:prstGeom prst="rect">
+            <a:avLst/>
+          </a:prstGeom>
+          <a:noFill/>
+          <a:ln/>
+        </p:spPr>
+        <p:txBody>
+          <a:bodyPr wrap="square" lIns="0" tIns="0" rIns="0" bIns="0" rtlCol="0" anchor="ctr"/>
+          <a:lstStyle/>
+          <a:p>
+            <a:pPr algn="r" indent="0" marL="0">
+              <a:buNone/>
+            </a:pPr>
+            <a:r>
+              <a:rPr lang="en-US" sz="900" dirty="0">
+                <a:solidFill>
+                  <a:srgbClr val="6B7280"/>
+                </a:solidFill>
+                <a:latin typeface="Calibri" pitchFamily="34" charset="0"/>
+                <a:ea typeface="Calibri" pitchFamily="34" charset="-122"/>
+                <a:cs typeface="Calibri" pitchFamily="34" charset="-120"/>
+              </a:rPr>
+              <a:t>13</a:t>
             </a:r>
             <a:endParaRPr lang="en-US" sz="900" dirty="0"/>
           </a:p>
@@ -3446,18 +4265,18 @@
       </p:sp>
       <p:sp>
         <p:nvSpPr>
-          <p:cNvPr id="5" name="Shape 3"/>
-          <p:cNvSpPr/>
-          <p:nvPr/>
-        </p:nvSpPr>
-        <p:spPr>
-          <a:xfrm>
-            <a:off x="640080" y="1188720"/>
-            <a:ext cx="7863840" cy="731520"/>
+          <p:cNvPr id="6" name="Shape 4"/>
+          <p:cNvSpPr/>
+          <p:nvPr/>
+        </p:nvSpPr>
+        <p:spPr>
+          <a:xfrm>
+            <a:off x="457200" y="1417320"/>
+            <a:ext cx="1965960" cy="1508760"/>
           </a:xfrm>
           <a:prstGeom prst="roundRect">
             <a:avLst>
-              <a:gd name="adj" fmla="val 10000"/>
+              <a:gd name="adj" fmla="val 4848"/>
             </a:avLst>
           </a:prstGeom>
           <a:solidFill>
@@ -3475,36 +4294,14 @@
       </p:sp>
       <p:sp>
         <p:nvSpPr>
-          <p:cNvPr id="6" name="Shape 4"/>
-          <p:cNvSpPr/>
-          <p:nvPr/>
-        </p:nvSpPr>
-        <p:spPr>
-          <a:xfrm>
-            <a:off x="822960" y="1325880"/>
-            <a:ext cx="502920" cy="457200"/>
-          </a:xfrm>
-          <a:prstGeom prst="roundRect">
-            <a:avLst>
-              <a:gd name="adj" fmla="val 10000"/>
-            </a:avLst>
-          </a:prstGeom>
-          <a:solidFill>
-            <a:srgbClr val="3B82F6"/>
-          </a:solidFill>
-          <a:ln/>
-        </p:spPr>
-      </p:sp>
-      <p:sp>
-        <p:nvSpPr>
           <p:cNvPr id="7" name="Text 5"/>
           <p:cNvSpPr/>
           <p:nvPr/>
         </p:nvSpPr>
         <p:spPr>
           <a:xfrm>
-            <a:off x="822960" y="1325880"/>
-            <a:ext cx="502920" cy="457200"/>
+            <a:off x="457200" y="1508760"/>
+            <a:ext cx="1965960" cy="457200"/>
           </a:xfrm>
           <a:prstGeom prst="rect">
             <a:avLst/>
@@ -3520,17 +4317,17 @@
               <a:buNone/>
             </a:pPr>
             <a:r>
-              <a:rPr lang="en-US" sz="1100" b="1" dirty="0">
-                <a:solidFill>
-                  <a:srgbClr val="FFFFFF"/>
-                </a:solidFill>
-                <a:latin typeface="Arial" pitchFamily="34" charset="0"/>
-                <a:ea typeface="Arial" pitchFamily="34" charset="-122"/>
-                <a:cs typeface="Arial" pitchFamily="34" charset="-120"/>
-              </a:rPr>
-              <a:t>P1</a:t>
-            </a:r>
-            <a:endParaRPr lang="en-US" sz="1100" dirty="0"/>
+              <a:rPr lang="en-US" sz="2400" dirty="0">
+                <a:solidFill>
+                  <a:srgbClr val="3B82F6"/>
+                </a:solidFill>
+                <a:latin typeface="Arial Black" pitchFamily="34" charset="0"/>
+                <a:ea typeface="Arial Black" pitchFamily="34" charset="-122"/>
+                <a:cs typeface="Arial Black" pitchFamily="34" charset="-120"/>
+              </a:rPr>
+              <a:t>1-2 hrs</a:t>
+            </a:r>
+            <a:endParaRPr lang="en-US" sz="2400" dirty="0"/>
           </a:p>
         </p:txBody>
       </p:sp>
@@ -3542,71 +4339,32 @@
         </p:nvSpPr>
         <p:spPr>
           <a:xfrm>
-            <a:off x="1508760" y="1298448"/>
-            <a:ext cx="3657600" cy="274320"/>
-          </a:xfrm>
-          <a:prstGeom prst="rect">
-            <a:avLst/>
-          </a:prstGeom>
-          <a:noFill/>
-          <a:ln/>
-        </p:spPr>
-        <p:txBody>
-          <a:bodyPr wrap="square" lIns="0" tIns="0" rIns="0" bIns="0" rtlCol="0" anchor="ctr"/>
-          <a:lstStyle/>
-          <a:p>
-            <a:pPr indent="0" marL="0">
-              <a:buNone/>
-            </a:pPr>
-            <a:r>
-              <a:rPr lang="en-US" sz="1300" b="1" dirty="0">
+            <a:off x="548640" y="2011680"/>
+            <a:ext cx="1783080" cy="365760"/>
+          </a:xfrm>
+          <a:prstGeom prst="rect">
+            <a:avLst/>
+          </a:prstGeom>
+          <a:noFill/>
+          <a:ln/>
+        </p:spPr>
+        <p:txBody>
+          <a:bodyPr wrap="square" lIns="0" tIns="0" rIns="0" bIns="0" rtlCol="0" anchor="ctr"/>
+          <a:lstStyle/>
+          <a:p>
+            <a:pPr algn="ctr" indent="0" marL="0">
+              <a:buNone/>
+            </a:pPr>
+            <a:r>
+              <a:rPr lang="en-US" sz="1000" b="1" dirty="0">
                 <a:solidFill>
                   <a:srgbClr val="111827"/>
-                </a:solidFill>
-                <a:latin typeface="Arial" pitchFamily="34" charset="0"/>
-                <a:ea typeface="Arial" pitchFamily="34" charset="-122"/>
-                <a:cs typeface="Arial" pitchFamily="34" charset="-120"/>
-              </a:rPr>
-              <a:t>Portal replacing CAM</a:t>
-            </a:r>
-            <a:endParaRPr lang="en-US" sz="1300" dirty="0"/>
-          </a:p>
-        </p:txBody>
-      </p:sp>
-      <p:sp>
-        <p:nvSpPr>
-          <p:cNvPr id="9" name="Text 7"/>
-          <p:cNvSpPr/>
-          <p:nvPr/>
-        </p:nvSpPr>
-        <p:spPr>
-          <a:xfrm>
-            <a:off x="1508760" y="1572768"/>
-            <a:ext cx="6766560" cy="274320"/>
-          </a:xfrm>
-          <a:prstGeom prst="rect">
-            <a:avLst/>
-          </a:prstGeom>
-          <a:noFill/>
-          <a:ln/>
-        </p:spPr>
-        <p:txBody>
-          <a:bodyPr wrap="square" lIns="0" tIns="0" rIns="0" bIns="0" rtlCol="0" anchor="ctr"/>
-          <a:lstStyle/>
-          <a:p>
-            <a:pPr indent="0" marL="0">
-              <a:buNone/>
-            </a:pPr>
-            <a:r>
-              <a:rPr lang="en-US" sz="1000" dirty="0">
-                <a:solidFill>
-                  <a:srgbClr val="6B7280"/>
                 </a:solidFill>
                 <a:latin typeface="Calibri" pitchFamily="34" charset="0"/>
                 <a:ea typeface="Calibri" pitchFamily="34" charset="-122"/>
                 <a:cs typeface="Calibri" pitchFamily="34" charset="-120"/>
               </a:rPr>
-              <a:t>Browse, upload, edit, export — full underwriter workflow</a:t>
+              <a:t>saved per unparseable statement</a:t>
             </a:r>
             <a:endParaRPr lang="en-US" sz="1000" dirty="0"/>
           </a:p>
@@ -3614,18 +4372,57 @@
       </p:sp>
       <p:sp>
         <p:nvSpPr>
+          <p:cNvPr id="9" name="Text 7"/>
+          <p:cNvSpPr/>
+          <p:nvPr/>
+        </p:nvSpPr>
+        <p:spPr>
+          <a:xfrm>
+            <a:off x="548640" y="2377440"/>
+            <a:ext cx="1783080" cy="320040"/>
+          </a:xfrm>
+          <a:prstGeom prst="rect">
+            <a:avLst/>
+          </a:prstGeom>
+          <a:noFill/>
+          <a:ln/>
+        </p:spPr>
+        <p:txBody>
+          <a:bodyPr wrap="square" lIns="0" tIns="0" rIns="0" bIns="0" rtlCol="0" anchor="ctr"/>
+          <a:lstStyle/>
+          <a:p>
+            <a:pPr algn="ctr" indent="0" marL="0">
+              <a:buNone/>
+            </a:pPr>
+            <a:r>
+              <a:rPr lang="en-US" sz="900" dirty="0">
+                <a:solidFill>
+                  <a:srgbClr val="6B7280"/>
+                </a:solidFill>
+                <a:latin typeface="Calibri" pitchFamily="34" charset="0"/>
+                <a:ea typeface="Calibri" pitchFamily="34" charset="-122"/>
+                <a:cs typeface="Calibri" pitchFamily="34" charset="-120"/>
+              </a:rPr>
+              <a:t>~20% of all cases</a:t>
+            </a:r>
+            <a:endParaRPr lang="en-US" sz="900" dirty="0"/>
+          </a:p>
+        </p:txBody>
+      </p:sp>
+      <p:sp>
+        <p:nvSpPr>
           <p:cNvPr id="10" name="Shape 8"/>
           <p:cNvSpPr/>
           <p:nvPr/>
         </p:nvSpPr>
         <p:spPr>
           <a:xfrm>
-            <a:off x="640080" y="2057400"/>
-            <a:ext cx="7863840" cy="731520"/>
+            <a:off x="2606040" y="1417320"/>
+            <a:ext cx="1965960" cy="1508760"/>
           </a:xfrm>
           <a:prstGeom prst="roundRect">
             <a:avLst>
-              <a:gd name="adj" fmla="val 10000"/>
+              <a:gd name="adj" fmla="val 4848"/>
             </a:avLst>
           </a:prstGeom>
           <a:solidFill>
@@ -3643,25 +4440,42 @@
       </p:sp>
       <p:sp>
         <p:nvSpPr>
-          <p:cNvPr id="11" name="Shape 9"/>
-          <p:cNvSpPr/>
-          <p:nvPr/>
-        </p:nvSpPr>
-        <p:spPr>
-          <a:xfrm>
-            <a:off x="822960" y="2194560"/>
-            <a:ext cx="502920" cy="457200"/>
-          </a:xfrm>
-          <a:prstGeom prst="roundRect">
-            <a:avLst>
-              <a:gd name="adj" fmla="val 10000"/>
-            </a:avLst>
-          </a:prstGeom>
-          <a:solidFill>
-            <a:srgbClr val="16A34A"/>
-          </a:solidFill>
-          <a:ln/>
-        </p:spPr>
+          <p:cNvPr id="11" name="Text 9"/>
+          <p:cNvSpPr/>
+          <p:nvPr/>
+        </p:nvSpPr>
+        <p:spPr>
+          <a:xfrm>
+            <a:off x="2606040" y="1508760"/>
+            <a:ext cx="1965960" cy="457200"/>
+          </a:xfrm>
+          <a:prstGeom prst="rect">
+            <a:avLst/>
+          </a:prstGeom>
+          <a:noFill/>
+          <a:ln/>
+        </p:spPr>
+        <p:txBody>
+          <a:bodyPr wrap="square" lIns="0" tIns="0" rIns="0" bIns="0" rtlCol="0" anchor="ctr"/>
+          <a:lstStyle/>
+          <a:p>
+            <a:pPr algn="ctr" indent="0" marL="0">
+              <a:buNone/>
+            </a:pPr>
+            <a:r>
+              <a:rPr lang="en-US" sz="2400" dirty="0">
+                <a:solidFill>
+                  <a:srgbClr val="3B82F6"/>
+                </a:solidFill>
+                <a:latin typeface="Arial Black" pitchFamily="34" charset="0"/>
+                <a:ea typeface="Arial Black" pitchFamily="34" charset="-122"/>
+                <a:cs typeface="Arial Black" pitchFamily="34" charset="-120"/>
+              </a:rPr>
+              <a:t>15 min</a:t>
+            </a:r>
+            <a:endParaRPr lang="en-US" sz="2400" dirty="0"/>
+          </a:p>
+        </p:txBody>
       </p:sp>
       <p:sp>
         <p:nvSpPr>
@@ -3671,8 +4485,8 @@
         </p:nvSpPr>
         <p:spPr>
           <a:xfrm>
-            <a:off x="822960" y="2194560"/>
-            <a:ext cx="502920" cy="457200"/>
+            <a:off x="2697480" y="2011680"/>
+            <a:ext cx="1783080" cy="365760"/>
           </a:xfrm>
           <a:prstGeom prst="rect">
             <a:avLst/>
@@ -3688,93 +4502,15 @@
               <a:buNone/>
             </a:pPr>
             <a:r>
-              <a:rPr lang="en-US" sz="1100" b="1" dirty="0">
-                <a:solidFill>
-                  <a:srgbClr val="FFFFFF"/>
-                </a:solidFill>
-                <a:latin typeface="Arial" pitchFamily="34" charset="0"/>
-                <a:ea typeface="Arial" pitchFamily="34" charset="-122"/>
-                <a:cs typeface="Arial" pitchFamily="34" charset="-120"/>
-              </a:rPr>
-              <a:t>P2</a:t>
-            </a:r>
-            <a:endParaRPr lang="en-US" sz="1100" dirty="0"/>
-          </a:p>
-        </p:txBody>
-      </p:sp>
-      <p:sp>
-        <p:nvSpPr>
-          <p:cNvPr id="13" name="Text 11"/>
-          <p:cNvSpPr/>
-          <p:nvPr/>
-        </p:nvSpPr>
-        <p:spPr>
-          <a:xfrm>
-            <a:off x="1508760" y="2167128"/>
-            <a:ext cx="3657600" cy="274320"/>
-          </a:xfrm>
-          <a:prstGeom prst="rect">
-            <a:avLst/>
-          </a:prstGeom>
-          <a:noFill/>
-          <a:ln/>
-        </p:spPr>
-        <p:txBody>
-          <a:bodyPr wrap="square" lIns="0" tIns="0" rIns="0" bIns="0" rtlCol="0" anchor="ctr"/>
-          <a:lstStyle/>
-          <a:p>
-            <a:pPr indent="0" marL="0">
-              <a:buNone/>
-            </a:pPr>
-            <a:r>
-              <a:rPr lang="en-US" sz="1300" b="1" dirty="0">
+              <a:rPr lang="en-US" sz="1000" b="1" dirty="0">
                 <a:solidFill>
                   <a:srgbClr val="111827"/>
-                </a:solidFill>
-                <a:latin typeface="Arial" pitchFamily="34" charset="0"/>
-                <a:ea typeface="Arial" pitchFamily="34" charset="-122"/>
-                <a:cs typeface="Arial" pitchFamily="34" charset="-120"/>
-              </a:rPr>
-              <a:t>Extend learning loop</a:t>
-            </a:r>
-            <a:endParaRPr lang="en-US" sz="1300" dirty="0"/>
-          </a:p>
-        </p:txBody>
-      </p:sp>
-      <p:sp>
-        <p:nvSpPr>
-          <p:cNvPr id="14" name="Text 12"/>
-          <p:cNvSpPr/>
-          <p:nvPr/>
-        </p:nvSpPr>
-        <p:spPr>
-          <a:xfrm>
-            <a:off x="1508760" y="2441448"/>
-            <a:ext cx="6766560" cy="274320"/>
-          </a:xfrm>
-          <a:prstGeom prst="rect">
-            <a:avLst/>
-          </a:prstGeom>
-          <a:noFill/>
-          <a:ln/>
-        </p:spPr>
-        <p:txBody>
-          <a:bodyPr wrap="square" lIns="0" tIns="0" rIns="0" bIns="0" rtlCol="0" anchor="ctr"/>
-          <a:lstStyle/>
-          <a:p>
-            <a:pPr indent="0" marL="0">
-              <a:buNone/>
-            </a:pPr>
-            <a:r>
-              <a:rPr lang="en-US" sz="1000" dirty="0">
-                <a:solidFill>
-                  <a:srgbClr val="6B7280"/>
                 </a:solidFill>
                 <a:latin typeface="Calibri" pitchFamily="34" charset="0"/>
                 <a:ea typeface="Calibri" pitchFamily="34" charset="-122"/>
                 <a:cs typeface="Calibri" pitchFamily="34" charset="-120"/>
               </a:rPr>
-              <a:t>Promote LLM-text formats into learned recipes for non-tabular statements</a:t>
+              <a:t>review replaces manual CAM fill</a:t>
             </a:r>
             <a:endParaRPr lang="en-US" sz="1000" dirty="0"/>
           </a:p>
@@ -3782,18 +4518,57 @@
       </p:sp>
       <p:sp>
         <p:nvSpPr>
-          <p:cNvPr id="15" name="Shape 13"/>
-          <p:cNvSpPr/>
-          <p:nvPr/>
-        </p:nvSpPr>
-        <p:spPr>
-          <a:xfrm>
-            <a:off x="640080" y="2926080"/>
-            <a:ext cx="7863840" cy="731520"/>
+          <p:cNvPr id="13" name="Text 11"/>
+          <p:cNvSpPr/>
+          <p:nvPr/>
+        </p:nvSpPr>
+        <p:spPr>
+          <a:xfrm>
+            <a:off x="2697480" y="2377440"/>
+            <a:ext cx="1783080" cy="320040"/>
+          </a:xfrm>
+          <a:prstGeom prst="rect">
+            <a:avLst/>
+          </a:prstGeom>
+          <a:noFill/>
+          <a:ln/>
+        </p:spPr>
+        <p:txBody>
+          <a:bodyPr wrap="square" lIns="0" tIns="0" rIns="0" bIns="0" rtlCol="0" anchor="ctr"/>
+          <a:lstStyle/>
+          <a:p>
+            <a:pPr algn="ctr" indent="0" marL="0">
+              <a:buNone/>
+            </a:pPr>
+            <a:r>
+              <a:rPr lang="en-US" sz="900" dirty="0">
+                <a:solidFill>
+                  <a:srgbClr val="6B7280"/>
+                </a:solidFill>
+                <a:latin typeface="Calibri" pitchFamily="34" charset="0"/>
+                <a:ea typeface="Calibri" pitchFamily="34" charset="-122"/>
+                <a:cs typeface="Calibri" pitchFamily="34" charset="-120"/>
+              </a:rPr>
+              <a:t>from hours → minutes</a:t>
+            </a:r>
+            <a:endParaRPr lang="en-US" sz="900" dirty="0"/>
+          </a:p>
+        </p:txBody>
+      </p:sp>
+      <p:sp>
+        <p:nvSpPr>
+          <p:cNvPr id="14" name="Shape 12"/>
+          <p:cNvSpPr/>
+          <p:nvPr/>
+        </p:nvSpPr>
+        <p:spPr>
+          <a:xfrm>
+            <a:off x="4754880" y="1417320"/>
+            <a:ext cx="1965960" cy="1508760"/>
           </a:xfrm>
           <a:prstGeom prst="roundRect">
             <a:avLst>
-              <a:gd name="adj" fmla="val 10000"/>
+              <a:gd name="adj" fmla="val 4848"/>
             </a:avLst>
           </a:prstGeom>
           <a:solidFill>
@@ -3811,36 +4586,14 @@
       </p:sp>
       <p:sp>
         <p:nvSpPr>
-          <p:cNvPr id="16" name="Shape 14"/>
-          <p:cNvSpPr/>
-          <p:nvPr/>
-        </p:nvSpPr>
-        <p:spPr>
-          <a:xfrm>
-            <a:off x="822960" y="3063240"/>
-            <a:ext cx="502920" cy="457200"/>
-          </a:xfrm>
-          <a:prstGeom prst="roundRect">
-            <a:avLst>
-              <a:gd name="adj" fmla="val 10000"/>
-            </a:avLst>
-          </a:prstGeom>
-          <a:solidFill>
-            <a:srgbClr val="F59E0B"/>
-          </a:solidFill>
-          <a:ln/>
-        </p:spPr>
-      </p:sp>
-      <p:sp>
-        <p:nvSpPr>
-          <p:cNvPr id="17" name="Text 15"/>
-          <p:cNvSpPr/>
-          <p:nvPr/>
-        </p:nvSpPr>
-        <p:spPr>
-          <a:xfrm>
-            <a:off x="822960" y="3063240"/>
-            <a:ext cx="502920" cy="457200"/>
+          <p:cNvPr id="15" name="Text 13"/>
+          <p:cNvSpPr/>
+          <p:nvPr/>
+        </p:nvSpPr>
+        <p:spPr>
+          <a:xfrm>
+            <a:off x="4754880" y="1508760"/>
+            <a:ext cx="1965960" cy="457200"/>
           </a:xfrm>
           <a:prstGeom prst="rect">
             <a:avLst/>
@@ -3856,93 +4609,54 @@
               <a:buNone/>
             </a:pPr>
             <a:r>
-              <a:rPr lang="en-US" sz="1100" b="1" dirty="0">
-                <a:solidFill>
-                  <a:srgbClr val="FFFFFF"/>
-                </a:solidFill>
-                <a:latin typeface="Arial" pitchFamily="34" charset="0"/>
-                <a:ea typeface="Arial" pitchFamily="34" charset="-122"/>
-                <a:cs typeface="Arial" pitchFamily="34" charset="-120"/>
-              </a:rPr>
-              <a:t>P3</a:t>
-            </a:r>
-            <a:endParaRPr lang="en-US" sz="1100" dirty="0"/>
-          </a:p>
-        </p:txBody>
-      </p:sp>
-      <p:sp>
-        <p:nvSpPr>
-          <p:cNvPr id="18" name="Text 16"/>
-          <p:cNvSpPr/>
-          <p:nvPr/>
-        </p:nvSpPr>
-        <p:spPr>
-          <a:xfrm>
-            <a:off x="1508760" y="3035808"/>
-            <a:ext cx="3657600" cy="274320"/>
-          </a:xfrm>
-          <a:prstGeom prst="rect">
-            <a:avLst/>
-          </a:prstGeom>
-          <a:noFill/>
-          <a:ln/>
-        </p:spPr>
-        <p:txBody>
-          <a:bodyPr wrap="square" lIns="0" tIns="0" rIns="0" bIns="0" rtlCol="0" anchor="ctr"/>
-          <a:lstStyle/>
-          <a:p>
-            <a:pPr indent="0" marL="0">
-              <a:buNone/>
-            </a:pPr>
-            <a:r>
-              <a:rPr lang="en-US" sz="1300" b="1" dirty="0">
+              <a:rPr lang="en-US" sz="2400" dirty="0">
+                <a:solidFill>
+                  <a:srgbClr val="3B82F6"/>
+                </a:solidFill>
+                <a:latin typeface="Arial Black" pitchFamily="34" charset="0"/>
+                <a:ea typeface="Arial Black" pitchFamily="34" charset="-122"/>
+                <a:cs typeface="Arial Black" pitchFamily="34" charset="-120"/>
+              </a:rPr>
+              <a:t>100%</a:t>
+            </a:r>
+            <a:endParaRPr lang="en-US" sz="2400" dirty="0"/>
+          </a:p>
+        </p:txBody>
+      </p:sp>
+      <p:sp>
+        <p:nvSpPr>
+          <p:cNvPr id="16" name="Text 14"/>
+          <p:cNvSpPr/>
+          <p:nvPr/>
+        </p:nvSpPr>
+        <p:spPr>
+          <a:xfrm>
+            <a:off x="4846320" y="2011680"/>
+            <a:ext cx="1783080" cy="365760"/>
+          </a:xfrm>
+          <a:prstGeom prst="rect">
+            <a:avLst/>
+          </a:prstGeom>
+          <a:noFill/>
+          <a:ln/>
+        </p:spPr>
+        <p:txBody>
+          <a:bodyPr wrap="square" lIns="0" tIns="0" rIns="0" bIns="0" rtlCol="0" anchor="ctr"/>
+          <a:lstStyle/>
+          <a:p>
+            <a:pPr algn="ctr" indent="0" marL="0">
+              <a:buNone/>
+            </a:pPr>
+            <a:r>
+              <a:rPr lang="en-US" sz="1000" b="1" dirty="0">
                 <a:solidFill>
                   <a:srgbClr val="111827"/>
-                </a:solidFill>
-                <a:latin typeface="Arial" pitchFamily="34" charset="0"/>
-                <a:ea typeface="Arial" pitchFamily="34" charset="-122"/>
-                <a:cs typeface="Arial" pitchFamily="34" charset="-120"/>
-              </a:rPr>
-              <a:t>Beyond bank statements</a:t>
-            </a:r>
-            <a:endParaRPr lang="en-US" sz="1300" dirty="0"/>
-          </a:p>
-        </p:txBody>
-      </p:sp>
-      <p:sp>
-        <p:nvSpPr>
-          <p:cNvPr id="19" name="Text 17"/>
-          <p:cNvSpPr/>
-          <p:nvPr/>
-        </p:nvSpPr>
-        <p:spPr>
-          <a:xfrm>
-            <a:off x="1508760" y="3310128"/>
-            <a:ext cx="6766560" cy="274320"/>
-          </a:xfrm>
-          <a:prstGeom prst="rect">
-            <a:avLst/>
-          </a:prstGeom>
-          <a:noFill/>
-          <a:ln/>
-        </p:spPr>
-        <p:txBody>
-          <a:bodyPr wrap="square" lIns="0" tIns="0" rIns="0" bIns="0" rtlCol="0" anchor="ctr"/>
-          <a:lstStyle/>
-          <a:p>
-            <a:pPr indent="0" marL="0">
-              <a:buNone/>
-            </a:pPr>
-            <a:r>
-              <a:rPr lang="en-US" sz="1000" dirty="0">
-                <a:solidFill>
-                  <a:srgbClr val="6B7280"/>
                 </a:solidFill>
                 <a:latin typeface="Calibri" pitchFamily="34" charset="0"/>
                 <a:ea typeface="Calibri" pitchFamily="34" charset="-122"/>
                 <a:cs typeface="Calibri" pitchFamily="34" charset="-120"/>
               </a:rPr>
-              <a:t>Extend parsing + learning to GST, ITR, KYC documents</a:t>
+              <a:t>consistent automated checks</a:t>
             </a:r>
             <a:endParaRPr lang="en-US" sz="1000" dirty="0"/>
           </a:p>
@@ -3950,18 +4664,57 @@
       </p:sp>
       <p:sp>
         <p:nvSpPr>
-          <p:cNvPr id="20" name="Shape 18"/>
-          <p:cNvSpPr/>
-          <p:nvPr/>
-        </p:nvSpPr>
-        <p:spPr>
-          <a:xfrm>
-            <a:off x="640080" y="3794760"/>
-            <a:ext cx="7863840" cy="731520"/>
+          <p:cNvPr id="17" name="Text 15"/>
+          <p:cNvSpPr/>
+          <p:nvPr/>
+        </p:nvSpPr>
+        <p:spPr>
+          <a:xfrm>
+            <a:off x="4846320" y="2377440"/>
+            <a:ext cx="1783080" cy="320040"/>
+          </a:xfrm>
+          <a:prstGeom prst="rect">
+            <a:avLst/>
+          </a:prstGeom>
+          <a:noFill/>
+          <a:ln/>
+        </p:spPr>
+        <p:txBody>
+          <a:bodyPr wrap="square" lIns="0" tIns="0" rIns="0" bIns="0" rtlCol="0" anchor="ctr"/>
+          <a:lstStyle/>
+          <a:p>
+            <a:pPr algn="ctr" indent="0" marL="0">
+              <a:buNone/>
+            </a:pPr>
+            <a:r>
+              <a:rPr lang="en-US" sz="900" dirty="0">
+                <a:solidFill>
+                  <a:srgbClr val="6B7280"/>
+                </a:solidFill>
+                <a:latin typeface="Calibri" pitchFamily="34" charset="0"/>
+                <a:ea typeface="Calibri" pitchFamily="34" charset="-122"/>
+                <a:cs typeface="Calibri" pitchFamily="34" charset="-120"/>
+              </a:rPr>
+              <a:t>dedupe, GSTIN, name match</a:t>
+            </a:r>
+            <a:endParaRPr lang="en-US" sz="900" dirty="0"/>
+          </a:p>
+        </p:txBody>
+      </p:sp>
+      <p:sp>
+        <p:nvSpPr>
+          <p:cNvPr id="18" name="Shape 16"/>
+          <p:cNvSpPr/>
+          <p:nvPr/>
+        </p:nvSpPr>
+        <p:spPr>
+          <a:xfrm>
+            <a:off x="6903720" y="1417320"/>
+            <a:ext cx="1965960" cy="1508760"/>
           </a:xfrm>
           <a:prstGeom prst="roundRect">
             <a:avLst>
-              <a:gd name="adj" fmla="val 10000"/>
+              <a:gd name="adj" fmla="val 4848"/>
             </a:avLst>
           </a:prstGeom>
           <a:solidFill>
@@ -3979,36 +4732,14 @@
       </p:sp>
       <p:sp>
         <p:nvSpPr>
-          <p:cNvPr id="21" name="Shape 19"/>
-          <p:cNvSpPr/>
-          <p:nvPr/>
-        </p:nvSpPr>
-        <p:spPr>
-          <a:xfrm>
-            <a:off x="822960" y="3931920"/>
-            <a:ext cx="502920" cy="457200"/>
-          </a:xfrm>
-          <a:prstGeom prst="roundRect">
-            <a:avLst>
-              <a:gd name="adj" fmla="val 10000"/>
-            </a:avLst>
-          </a:prstGeom>
-          <a:solidFill>
-            <a:srgbClr val="6B7280"/>
-          </a:solidFill>
-          <a:ln/>
-        </p:spPr>
-      </p:sp>
-      <p:sp>
-        <p:nvSpPr>
-          <p:cNvPr id="22" name="Text 20"/>
-          <p:cNvSpPr/>
-          <p:nvPr/>
-        </p:nvSpPr>
-        <p:spPr>
-          <a:xfrm>
-            <a:off x="822960" y="3931920"/>
-            <a:ext cx="502920" cy="457200"/>
+          <p:cNvPr id="19" name="Text 17"/>
+          <p:cNvSpPr/>
+          <p:nvPr/>
+        </p:nvSpPr>
+        <p:spPr>
+          <a:xfrm>
+            <a:off x="6903720" y="1508760"/>
+            <a:ext cx="1965960" cy="457200"/>
           </a:xfrm>
           <a:prstGeom prst="rect">
             <a:avLst/>
@@ -4024,93 +4755,54 @@
               <a:buNone/>
             </a:pPr>
             <a:r>
-              <a:rPr lang="en-US" sz="1100" b="1" dirty="0">
-                <a:solidFill>
-                  <a:srgbClr val="FFFFFF"/>
-                </a:solidFill>
-                <a:latin typeface="Arial" pitchFamily="34" charset="0"/>
-                <a:ea typeface="Arial" pitchFamily="34" charset="-122"/>
-                <a:cs typeface="Arial" pitchFamily="34" charset="-120"/>
-              </a:rPr>
-              <a:t>P4</a:t>
-            </a:r>
-            <a:endParaRPr lang="en-US" sz="1100" dirty="0"/>
-          </a:p>
-        </p:txBody>
-      </p:sp>
-      <p:sp>
-        <p:nvSpPr>
-          <p:cNvPr id="23" name="Text 21"/>
-          <p:cNvSpPr/>
-          <p:nvPr/>
-        </p:nvSpPr>
-        <p:spPr>
-          <a:xfrm>
-            <a:off x="1508760" y="3904488"/>
-            <a:ext cx="3657600" cy="274320"/>
-          </a:xfrm>
-          <a:prstGeom prst="rect">
-            <a:avLst/>
-          </a:prstGeom>
-          <a:noFill/>
-          <a:ln/>
-        </p:spPr>
-        <p:txBody>
-          <a:bodyPr wrap="square" lIns="0" tIns="0" rIns="0" bIns="0" rtlCol="0" anchor="ctr"/>
-          <a:lstStyle/>
-          <a:p>
-            <a:pPr indent="0" marL="0">
-              <a:buNone/>
-            </a:pPr>
-            <a:r>
-              <a:rPr lang="en-US" sz="1300" b="1" dirty="0">
+              <a:rPr lang="en-US" sz="2400" dirty="0">
+                <a:solidFill>
+                  <a:srgbClr val="3B82F6"/>
+                </a:solidFill>
+                <a:latin typeface="Arial Black" pitchFamily="34" charset="0"/>
+                <a:ea typeface="Arial Black" pitchFamily="34" charset="-122"/>
+                <a:cs typeface="Arial Black" pitchFamily="34" charset="-120"/>
+              </a:rPr>
+              <a:t>Linear</a:t>
+            </a:r>
+            <a:endParaRPr lang="en-US" sz="2400" dirty="0"/>
+          </a:p>
+        </p:txBody>
+      </p:sp>
+      <p:sp>
+        <p:nvSpPr>
+          <p:cNvPr id="20" name="Text 18"/>
+          <p:cNvSpPr/>
+          <p:nvPr/>
+        </p:nvSpPr>
+        <p:spPr>
+          <a:xfrm>
+            <a:off x="6995160" y="2011680"/>
+            <a:ext cx="1783080" cy="365760"/>
+          </a:xfrm>
+          <a:prstGeom prst="rect">
+            <a:avLst/>
+          </a:prstGeom>
+          <a:noFill/>
+          <a:ln/>
+        </p:spPr>
+        <p:txBody>
+          <a:bodyPr wrap="square" lIns="0" tIns="0" rIns="0" bIns="0" rtlCol="0" anchor="ctr"/>
+          <a:lstStyle/>
+          <a:p>
+            <a:pPr algn="ctr" indent="0" marL="0">
+              <a:buNone/>
+            </a:pPr>
+            <a:r>
+              <a:rPr lang="en-US" sz="1000" b="1" dirty="0">
                 <a:solidFill>
                   <a:srgbClr val="111827"/>
-                </a:solidFill>
-                <a:latin typeface="Arial" pitchFamily="34" charset="0"/>
-                <a:ea typeface="Arial" pitchFamily="34" charset="-122"/>
-                <a:cs typeface="Arial" pitchFamily="34" charset="-120"/>
-              </a:rPr>
-              <a:t>CE password affordance</a:t>
-            </a:r>
-            <a:endParaRPr lang="en-US" sz="1300" dirty="0"/>
-          </a:p>
-        </p:txBody>
-      </p:sp>
-      <p:sp>
-        <p:nvSpPr>
-          <p:cNvPr id="24" name="Text 22"/>
-          <p:cNvSpPr/>
-          <p:nvPr/>
-        </p:nvSpPr>
-        <p:spPr>
-          <a:xfrm>
-            <a:off x="1508760" y="4178808"/>
-            <a:ext cx="6766560" cy="274320"/>
-          </a:xfrm>
-          <a:prstGeom prst="rect">
-            <a:avLst/>
-          </a:prstGeom>
-          <a:noFill/>
-          <a:ln/>
-        </p:spPr>
-        <p:txBody>
-          <a:bodyPr wrap="square" lIns="0" tIns="0" rIns="0" bIns="0" rtlCol="0" anchor="ctr"/>
-          <a:lstStyle/>
-          <a:p>
-            <a:pPr indent="0" marL="0">
-              <a:buNone/>
-            </a:pPr>
-            <a:r>
-              <a:rPr lang="en-US" sz="1000" dirty="0">
-                <a:solidFill>
-                  <a:srgbClr val="6B7280"/>
                 </a:solidFill>
                 <a:latin typeface="Calibri" pitchFamily="34" charset="0"/>
                 <a:ea typeface="Calibri" pitchFamily="34" charset="-122"/>
                 <a:cs typeface="Calibri" pitchFamily="34" charset="-120"/>
               </a:rPr>
-              <a:t>CE-supplied passwords for PDFs no identity-derived candidate unlocks</a:t>
+              <a:t>scale without more analysts</a:t>
             </a:r>
             <a:endParaRPr lang="en-US" sz="1000" dirty="0"/>
           </a:p>
@@ -4118,43 +4810,14 @@
       </p:sp>
       <p:sp>
         <p:nvSpPr>
-          <p:cNvPr id="25" name="Shape 23"/>
-          <p:cNvSpPr/>
-          <p:nvPr/>
-        </p:nvSpPr>
-        <p:spPr>
-          <a:xfrm>
-            <a:off x="2286000" y="4572000"/>
-            <a:ext cx="4572000" cy="411480"/>
-          </a:xfrm>
-          <a:prstGeom prst="roundRect">
-            <a:avLst>
-              <a:gd name="adj" fmla="val 17778"/>
-            </a:avLst>
-          </a:prstGeom>
-          <a:solidFill>
-            <a:srgbClr val="EBF5FF"/>
-          </a:solidFill>
-          <a:ln/>
-          <a:effectLst>
-            <a:outerShdw sx="100000" sy="100000" kx="0" ky="0" algn="bl" rotWithShape="0" blurRad="50800" dist="12700" dir="8100000">
-              <a:srgbClr val="000000">
-                <a:alpha val="8000"/>
-              </a:srgbClr>
-            </a:outerShdw>
-          </a:effectLst>
-        </p:spPr>
-      </p:sp>
-      <p:sp>
-        <p:nvSpPr>
-          <p:cNvPr id="26" name="Text 24"/>
-          <p:cNvSpPr/>
-          <p:nvPr/>
-        </p:nvSpPr>
-        <p:spPr>
-          <a:xfrm>
-            <a:off x="2286000" y="4572000"/>
-            <a:ext cx="4572000" cy="411480"/>
+          <p:cNvPr id="21" name="Text 19"/>
+          <p:cNvSpPr/>
+          <p:nvPr/>
+        </p:nvSpPr>
+        <p:spPr>
+          <a:xfrm>
+            <a:off x="6995160" y="2377440"/>
+            <a:ext cx="1783080" cy="320040"/>
           </a:xfrm>
           <a:prstGeom prst="rect">
             <a:avLst/>
@@ -4170,17 +4833,123 @@
               <a:buNone/>
             </a:pPr>
             <a:r>
-              <a:rPr lang="en-US" sz="1300" b="1" dirty="0">
-                <a:solidFill>
-                  <a:srgbClr val="2563EB"/>
-                </a:solidFill>
-                <a:latin typeface="Arial" pitchFamily="34" charset="0"/>
-                <a:ea typeface="Arial" pitchFamily="34" charset="-122"/>
-                <a:cs typeface="Arial" pitchFamily="34" charset="-120"/>
-              </a:rPr>
-              <a:t>Ask: Pilot on a live queue to quantify hours saved</a:t>
-            </a:r>
-            <a:endParaRPr lang="en-US" sz="1300" dirty="0"/>
+              <a:rPr lang="en-US" sz="900" dirty="0">
+                <a:solidFill>
+                  <a:srgbClr val="6B7280"/>
+                </a:solidFill>
+                <a:latin typeface="Calibri" pitchFamily="34" charset="0"/>
+                <a:ea typeface="Calibri" pitchFamily="34" charset="-122"/>
+                <a:cs typeface="Calibri" pitchFamily="34" charset="-120"/>
+              </a:rPr>
+              <a:t>compounding learn-from-LLM</a:t>
+            </a:r>
+            <a:endParaRPr lang="en-US" sz="900" dirty="0"/>
+          </a:p>
+        </p:txBody>
+      </p:sp>
+      <p:sp>
+        <p:nvSpPr>
+          <p:cNvPr id="22" name="Text 20"/>
+          <p:cNvSpPr/>
+          <p:nvPr/>
+        </p:nvSpPr>
+        <p:spPr>
+          <a:xfrm>
+            <a:off x="640080" y="3200400"/>
+            <a:ext cx="7863840" cy="1645920"/>
+          </a:xfrm>
+          <a:prstGeom prst="rect">
+            <a:avLst/>
+          </a:prstGeom>
+          <a:noFill/>
+          <a:ln/>
+        </p:spPr>
+        <p:txBody>
+          <a:bodyPr wrap="square" lIns="0" tIns="0" rIns="0" bIns="0" rtlCol="0" anchor="ctr"/>
+          <a:lstStyle/>
+          <a:p>
+            <a:pPr marL="342900" indent="-342900">
+              <a:lnSpc>
+                <a:spcPct val="135000"/>
+              </a:lnSpc>
+              <a:buSzPct val="100000"/>
+              <a:buChar char="•"/>
+            </a:pPr>
+            <a:r>
+              <a:rPr lang="en-US" sz="1100" dirty="0">
+                <a:solidFill>
+                  <a:srgbClr val="374151"/>
+                </a:solidFill>
+                <a:latin typeface="Calibri" pitchFamily="34" charset="0"/>
+                <a:ea typeface="Calibri" pitchFamily="34" charset="-122"/>
+                <a:cs typeface="Calibri" pitchFamily="34" charset="-120"/>
+              </a:rPr>
+              <a:t>Removes manual updation — auto-populate, review exceptions only</a:t>
+            </a:r>
+            <a:endParaRPr lang="en-US" sz="1100" dirty="0"/>
+          </a:p>
+          <a:p>
+            <a:pPr marL="342900" indent="-342900">
+              <a:lnSpc>
+                <a:spcPct val="135000"/>
+              </a:lnSpc>
+              <a:buSzPct val="100000"/>
+              <a:buChar char="•"/>
+            </a:pPr>
+            <a:r>
+              <a:rPr lang="en-US" sz="1100" dirty="0">
+                <a:solidFill>
+                  <a:srgbClr val="374151"/>
+                </a:solidFill>
+                <a:latin typeface="Calibri" pitchFamily="34" charset="0"/>
+                <a:ea typeface="Calibri" pitchFamily="34" charset="-122"/>
+                <a:cs typeface="Calibri" pitchFamily="34" charset="-120"/>
+              </a:rPr>
+              <a:t>Cuts CE↔CM back-and-forth — completeness check flags missing docs upfront</a:t>
+            </a:r>
+            <a:endParaRPr lang="en-US" sz="1100" dirty="0"/>
+          </a:p>
+          <a:p>
+            <a:pPr marL="342900" indent="-342900">
+              <a:lnSpc>
+                <a:spcPct val="135000"/>
+              </a:lnSpc>
+              <a:buSzPct val="100000"/>
+              <a:buChar char="•"/>
+            </a:pPr>
+            <a:r>
+              <a:rPr lang="en-US" sz="1100" dirty="0">
+                <a:solidFill>
+                  <a:srgbClr val="374151"/>
+                </a:solidFill>
+                <a:latin typeface="Calibri" pitchFamily="34" charset="0"/>
+                <a:ea typeface="Calibri" pitchFamily="34" charset="-122"/>
+                <a:cs typeface="Calibri" pitchFamily="34" charset="-120"/>
+              </a:rPr>
+              <a:t>Compounding returns — each new bank format is a one-time cost, then pure rules</a:t>
+            </a:r>
+            <a:endParaRPr lang="en-US" sz="1100" dirty="0"/>
+          </a:p>
+          <a:p>
+            <a:pPr marL="342900" indent="-342900">
+              <a:lnSpc>
+                <a:spcPct val="135000"/>
+              </a:lnSpc>
+              <a:buSzPct val="100000"/>
+              <a:buChar char="•"/>
+            </a:pPr>
+            <a:r>
+              <a:rPr lang="en-US" sz="1100" dirty="0">
+                <a:solidFill>
+                  <a:srgbClr val="374151"/>
+                </a:solidFill>
+                <a:latin typeface="Calibri" pitchFamily="34" charset="0"/>
+                <a:ea typeface="Calibri" pitchFamily="34" charset="-122"/>
+                <a:cs typeface="Calibri" pitchFamily="34" charset="-120"/>
+              </a:rPr>
+              <a:t>Scales linearly — more applications ≠ proportionally more analyst hours</a:t>
+            </a:r>
+            <a:endParaRPr lang="en-US" sz="1100" dirty="0"/>
           </a:p>
         </p:txBody>
       </p:sp>
@@ -4192,9 +4961,879 @@
 </p:sld>
 </file>
 
-<file path=ppt/slides/slide13.xml><?xml version="1.0" encoding="utf-8"?>
+<file path=ppt/slides/slide14.xml><?xml version="1.0" encoding="utf-8"?>
 <p:sld xmlns:a="http://schemas.openxmlformats.org/drawingml/2006/main" xmlns:r="http://schemas.openxmlformats.org/officeDocument/2006/relationships" xmlns:p="http://schemas.openxmlformats.org/presentationml/2006/main">
-  <p:cSld name="Slide 13">
+  <p:cSld name="Slide 14">
+    <p:bg>
+      <p:bgPr>
+        <a:solidFill>
+          <a:srgbClr val="FFFFFF"/>
+        </a:solidFill>
+      </p:bgPr>
+    </p:bg>
+    <p:spTree>
+      <p:nvGrpSpPr>
+        <p:cNvPr id="1" name=""/>
+        <p:cNvGrpSpPr/>
+        <p:nvPr/>
+      </p:nvGrpSpPr>
+      <p:grpSpPr>
+        <a:xfrm>
+          <a:off x="0" y="0"/>
+          <a:ext cx="0" cy="0"/>
+          <a:chOff x="0" y="0"/>
+          <a:chExt cx="0" cy="0"/>
+        </a:xfrm>
+      </p:grpSpPr>
+      <p:sp>
+        <p:nvSpPr>
+          <p:cNvPr id="2" name="Shape 0"/>
+          <p:cNvSpPr/>
+          <p:nvPr/>
+        </p:nvSpPr>
+        <p:spPr>
+          <a:xfrm>
+            <a:off x="0" y="0"/>
+            <a:ext cx="54864" cy="5143500"/>
+          </a:xfrm>
+          <a:prstGeom prst="rect">
+            <a:avLst/>
+          </a:prstGeom>
+          <a:solidFill>
+            <a:srgbClr val="3B82F6"/>
+          </a:solidFill>
+          <a:ln/>
+        </p:spPr>
+      </p:sp>
+      <p:sp>
+        <p:nvSpPr>
+          <p:cNvPr id="3" name="Text 1"/>
+          <p:cNvSpPr/>
+          <p:nvPr/>
+        </p:nvSpPr>
+        <p:spPr>
+          <a:xfrm>
+            <a:off x="640080" y="320040"/>
+            <a:ext cx="7863840" cy="502920"/>
+          </a:xfrm>
+          <a:prstGeom prst="rect">
+            <a:avLst/>
+          </a:prstGeom>
+          <a:noFill/>
+          <a:ln/>
+        </p:spPr>
+        <p:txBody>
+          <a:bodyPr wrap="square" lIns="0" tIns="0" rIns="0" bIns="0" rtlCol="0" anchor="ctr"/>
+          <a:lstStyle/>
+          <a:p>
+            <a:pPr indent="0" marL="0">
+              <a:buNone/>
+            </a:pPr>
+            <a:r>
+              <a:rPr lang="en-US" sz="2800" b="1" dirty="0">
+                <a:solidFill>
+                  <a:srgbClr val="111827"/>
+                </a:solidFill>
+                <a:latin typeface="Arial Black" pitchFamily="34" charset="0"/>
+                <a:ea typeface="Arial Black" pitchFamily="34" charset="-122"/>
+                <a:cs typeface="Arial Black" pitchFamily="34" charset="-120"/>
+              </a:rPr>
+              <a:t>Roadmap &amp; Ask</a:t>
+            </a:r>
+            <a:endParaRPr lang="en-US" sz="2800" dirty="0"/>
+          </a:p>
+        </p:txBody>
+      </p:sp>
+      <p:sp>
+        <p:nvSpPr>
+          <p:cNvPr id="4" name="Text 2"/>
+          <p:cNvSpPr/>
+          <p:nvPr/>
+        </p:nvSpPr>
+        <p:spPr>
+          <a:xfrm>
+            <a:off x="8503920" y="4800600"/>
+            <a:ext cx="457200" cy="274320"/>
+          </a:xfrm>
+          <a:prstGeom prst="rect">
+            <a:avLst/>
+          </a:prstGeom>
+          <a:noFill/>
+          <a:ln/>
+        </p:spPr>
+        <p:txBody>
+          <a:bodyPr wrap="square" lIns="0" tIns="0" rIns="0" bIns="0" rtlCol="0" anchor="ctr"/>
+          <a:lstStyle/>
+          <a:p>
+            <a:pPr algn="r" indent="0" marL="0">
+              <a:buNone/>
+            </a:pPr>
+            <a:r>
+              <a:rPr lang="en-US" sz="900" dirty="0">
+                <a:solidFill>
+                  <a:srgbClr val="6B7280"/>
+                </a:solidFill>
+                <a:latin typeface="Calibri" pitchFamily="34" charset="0"/>
+                <a:ea typeface="Calibri" pitchFamily="34" charset="-122"/>
+                <a:cs typeface="Calibri" pitchFamily="34" charset="-120"/>
+              </a:rPr>
+              <a:t>14</a:t>
+            </a:r>
+            <a:endParaRPr lang="en-US" sz="900" dirty="0"/>
+          </a:p>
+        </p:txBody>
+      </p:sp>
+      <p:sp>
+        <p:nvSpPr>
+          <p:cNvPr id="5" name="Shape 3"/>
+          <p:cNvSpPr/>
+          <p:nvPr/>
+        </p:nvSpPr>
+        <p:spPr>
+          <a:xfrm>
+            <a:off x="640080" y="1188720"/>
+            <a:ext cx="7863840" cy="731520"/>
+          </a:xfrm>
+          <a:prstGeom prst="roundRect">
+            <a:avLst>
+              <a:gd name="adj" fmla="val 10000"/>
+            </a:avLst>
+          </a:prstGeom>
+          <a:solidFill>
+            <a:srgbClr val="F4F5F7"/>
+          </a:solidFill>
+          <a:ln/>
+          <a:effectLst>
+            <a:outerShdw sx="100000" sy="100000" kx="0" ky="0" algn="bl" rotWithShape="0" blurRad="50800" dist="12700" dir="8100000">
+              <a:srgbClr val="000000">
+                <a:alpha val="8000"/>
+              </a:srgbClr>
+            </a:outerShdw>
+          </a:effectLst>
+        </p:spPr>
+      </p:sp>
+      <p:sp>
+        <p:nvSpPr>
+          <p:cNvPr id="6" name="Shape 4"/>
+          <p:cNvSpPr/>
+          <p:nvPr/>
+        </p:nvSpPr>
+        <p:spPr>
+          <a:xfrm>
+            <a:off x="822960" y="1325880"/>
+            <a:ext cx="502920" cy="457200"/>
+          </a:xfrm>
+          <a:prstGeom prst="roundRect">
+            <a:avLst>
+              <a:gd name="adj" fmla="val 10000"/>
+            </a:avLst>
+          </a:prstGeom>
+          <a:solidFill>
+            <a:srgbClr val="3B82F6"/>
+          </a:solidFill>
+          <a:ln/>
+        </p:spPr>
+      </p:sp>
+      <p:sp>
+        <p:nvSpPr>
+          <p:cNvPr id="7" name="Text 5"/>
+          <p:cNvSpPr/>
+          <p:nvPr/>
+        </p:nvSpPr>
+        <p:spPr>
+          <a:xfrm>
+            <a:off x="822960" y="1325880"/>
+            <a:ext cx="502920" cy="457200"/>
+          </a:xfrm>
+          <a:prstGeom prst="rect">
+            <a:avLst/>
+          </a:prstGeom>
+          <a:noFill/>
+          <a:ln/>
+        </p:spPr>
+        <p:txBody>
+          <a:bodyPr wrap="square" lIns="0" tIns="0" rIns="0" bIns="0" rtlCol="0" anchor="ctr"/>
+          <a:lstStyle/>
+          <a:p>
+            <a:pPr algn="ctr" indent="0" marL="0">
+              <a:buNone/>
+            </a:pPr>
+            <a:r>
+              <a:rPr lang="en-US" sz="1100" b="1" dirty="0">
+                <a:solidFill>
+                  <a:srgbClr val="FFFFFF"/>
+                </a:solidFill>
+                <a:latin typeface="Arial" pitchFamily="34" charset="0"/>
+                <a:ea typeface="Arial" pitchFamily="34" charset="-122"/>
+                <a:cs typeface="Arial" pitchFamily="34" charset="-120"/>
+              </a:rPr>
+              <a:t>P1</a:t>
+            </a:r>
+            <a:endParaRPr lang="en-US" sz="1100" dirty="0"/>
+          </a:p>
+        </p:txBody>
+      </p:sp>
+      <p:sp>
+        <p:nvSpPr>
+          <p:cNvPr id="8" name="Text 6"/>
+          <p:cNvSpPr/>
+          <p:nvPr/>
+        </p:nvSpPr>
+        <p:spPr>
+          <a:xfrm>
+            <a:off x="1508760" y="1298448"/>
+            <a:ext cx="3657600" cy="274320"/>
+          </a:xfrm>
+          <a:prstGeom prst="rect">
+            <a:avLst/>
+          </a:prstGeom>
+          <a:noFill/>
+          <a:ln/>
+        </p:spPr>
+        <p:txBody>
+          <a:bodyPr wrap="square" lIns="0" tIns="0" rIns="0" bIns="0" rtlCol="0" anchor="ctr"/>
+          <a:lstStyle/>
+          <a:p>
+            <a:pPr indent="0" marL="0">
+              <a:buNone/>
+            </a:pPr>
+            <a:r>
+              <a:rPr lang="en-US" sz="1300" b="1" dirty="0">
+                <a:solidFill>
+                  <a:srgbClr val="111827"/>
+                </a:solidFill>
+                <a:latin typeface="Arial" pitchFamily="34" charset="0"/>
+                <a:ea typeface="Arial" pitchFamily="34" charset="-122"/>
+                <a:cs typeface="Arial" pitchFamily="34" charset="-120"/>
+              </a:rPr>
+              <a:t>Portal replacing CAM</a:t>
+            </a:r>
+            <a:endParaRPr lang="en-US" sz="1300" dirty="0"/>
+          </a:p>
+        </p:txBody>
+      </p:sp>
+      <p:sp>
+        <p:nvSpPr>
+          <p:cNvPr id="9" name="Text 7"/>
+          <p:cNvSpPr/>
+          <p:nvPr/>
+        </p:nvSpPr>
+        <p:spPr>
+          <a:xfrm>
+            <a:off x="1508760" y="1572768"/>
+            <a:ext cx="6766560" cy="274320"/>
+          </a:xfrm>
+          <a:prstGeom prst="rect">
+            <a:avLst/>
+          </a:prstGeom>
+          <a:noFill/>
+          <a:ln/>
+        </p:spPr>
+        <p:txBody>
+          <a:bodyPr wrap="square" lIns="0" tIns="0" rIns="0" bIns="0" rtlCol="0" anchor="ctr"/>
+          <a:lstStyle/>
+          <a:p>
+            <a:pPr indent="0" marL="0">
+              <a:buNone/>
+            </a:pPr>
+            <a:r>
+              <a:rPr lang="en-US" sz="1000" dirty="0">
+                <a:solidFill>
+                  <a:srgbClr val="6B7280"/>
+                </a:solidFill>
+                <a:latin typeface="Calibri" pitchFamily="34" charset="0"/>
+                <a:ea typeface="Calibri" pitchFamily="34" charset="-122"/>
+                <a:cs typeface="Calibri" pitchFamily="34" charset="-120"/>
+              </a:rPr>
+              <a:t>Browse, upload, edit, export — full underwriter workflow</a:t>
+            </a:r>
+            <a:endParaRPr lang="en-US" sz="1000" dirty="0"/>
+          </a:p>
+        </p:txBody>
+      </p:sp>
+      <p:sp>
+        <p:nvSpPr>
+          <p:cNvPr id="10" name="Shape 8"/>
+          <p:cNvSpPr/>
+          <p:nvPr/>
+        </p:nvSpPr>
+        <p:spPr>
+          <a:xfrm>
+            <a:off x="640080" y="2057400"/>
+            <a:ext cx="7863840" cy="731520"/>
+          </a:xfrm>
+          <a:prstGeom prst="roundRect">
+            <a:avLst>
+              <a:gd name="adj" fmla="val 10000"/>
+            </a:avLst>
+          </a:prstGeom>
+          <a:solidFill>
+            <a:srgbClr val="F4F5F7"/>
+          </a:solidFill>
+          <a:ln/>
+          <a:effectLst>
+            <a:outerShdw sx="100000" sy="100000" kx="0" ky="0" algn="bl" rotWithShape="0" blurRad="50800" dist="12700" dir="8100000">
+              <a:srgbClr val="000000">
+                <a:alpha val="8000"/>
+              </a:srgbClr>
+            </a:outerShdw>
+          </a:effectLst>
+        </p:spPr>
+      </p:sp>
+      <p:sp>
+        <p:nvSpPr>
+          <p:cNvPr id="11" name="Shape 9"/>
+          <p:cNvSpPr/>
+          <p:nvPr/>
+        </p:nvSpPr>
+        <p:spPr>
+          <a:xfrm>
+            <a:off x="822960" y="2194560"/>
+            <a:ext cx="502920" cy="457200"/>
+          </a:xfrm>
+          <a:prstGeom prst="roundRect">
+            <a:avLst>
+              <a:gd name="adj" fmla="val 10000"/>
+            </a:avLst>
+          </a:prstGeom>
+          <a:solidFill>
+            <a:srgbClr val="DC2626"/>
+          </a:solidFill>
+          <a:ln/>
+        </p:spPr>
+      </p:sp>
+      <p:sp>
+        <p:nvSpPr>
+          <p:cNvPr id="12" name="Text 10"/>
+          <p:cNvSpPr/>
+          <p:nvPr/>
+        </p:nvSpPr>
+        <p:spPr>
+          <a:xfrm>
+            <a:off x="822960" y="2194560"/>
+            <a:ext cx="502920" cy="457200"/>
+          </a:xfrm>
+          <a:prstGeom prst="rect">
+            <a:avLst/>
+          </a:prstGeom>
+          <a:noFill/>
+          <a:ln/>
+        </p:spPr>
+        <p:txBody>
+          <a:bodyPr wrap="square" lIns="0" tIns="0" rIns="0" bIns="0" rtlCol="0" anchor="ctr"/>
+          <a:lstStyle/>
+          <a:p>
+            <a:pPr algn="ctr" indent="0" marL="0">
+              <a:buNone/>
+            </a:pPr>
+            <a:r>
+              <a:rPr lang="en-US" sz="1100" b="1" dirty="0">
+                <a:solidFill>
+                  <a:srgbClr val="FFFFFF"/>
+                </a:solidFill>
+                <a:latin typeface="Arial" pitchFamily="34" charset="0"/>
+                <a:ea typeface="Arial" pitchFamily="34" charset="-122"/>
+                <a:cs typeface="Arial" pitchFamily="34" charset="-120"/>
+              </a:rPr>
+              <a:t>P2</a:t>
+            </a:r>
+            <a:endParaRPr lang="en-US" sz="1100" dirty="0"/>
+          </a:p>
+        </p:txBody>
+      </p:sp>
+      <p:sp>
+        <p:nvSpPr>
+          <p:cNvPr id="13" name="Text 11"/>
+          <p:cNvSpPr/>
+          <p:nvPr/>
+        </p:nvSpPr>
+        <p:spPr>
+          <a:xfrm>
+            <a:off x="1508760" y="2167128"/>
+            <a:ext cx="3657600" cy="274320"/>
+          </a:xfrm>
+          <a:prstGeom prst="rect">
+            <a:avLst/>
+          </a:prstGeom>
+          <a:noFill/>
+          <a:ln/>
+        </p:spPr>
+        <p:txBody>
+          <a:bodyPr wrap="square" lIns="0" tIns="0" rIns="0" bIns="0" rtlCol="0" anchor="ctr"/>
+          <a:lstStyle/>
+          <a:p>
+            <a:pPr indent="0" marL="0">
+              <a:buNone/>
+            </a:pPr>
+            <a:r>
+              <a:rPr lang="en-US" sz="1300" b="1" dirty="0">
+                <a:solidFill>
+                  <a:srgbClr val="111827"/>
+                </a:solidFill>
+                <a:latin typeface="Arial" pitchFamily="34" charset="0"/>
+                <a:ea typeface="Arial" pitchFamily="34" charset="-122"/>
+                <a:cs typeface="Arial" pitchFamily="34" charset="-120"/>
+              </a:rPr>
+              <a:t>Fraud detection v2</a:t>
+            </a:r>
+            <a:endParaRPr lang="en-US" sz="1300" dirty="0"/>
+          </a:p>
+        </p:txBody>
+      </p:sp>
+      <p:sp>
+        <p:nvSpPr>
+          <p:cNvPr id="14" name="Text 12"/>
+          <p:cNvSpPr/>
+          <p:nvPr/>
+        </p:nvSpPr>
+        <p:spPr>
+          <a:xfrm>
+            <a:off x="1508760" y="2441448"/>
+            <a:ext cx="6766560" cy="274320"/>
+          </a:xfrm>
+          <a:prstGeom prst="rect">
+            <a:avLst/>
+          </a:prstGeom>
+          <a:noFill/>
+          <a:ln/>
+        </p:spPr>
+        <p:txBody>
+          <a:bodyPr wrap="square" lIns="0" tIns="0" rIns="0" bIns="0" rtlCol="0" anchor="ctr"/>
+          <a:lstStyle/>
+          <a:p>
+            <a:pPr indent="0" marL="0">
+              <a:buNone/>
+            </a:pPr>
+            <a:r>
+              <a:rPr lang="en-US" sz="1000" dirty="0">
+                <a:solidFill>
+                  <a:srgbClr val="6B7280"/>
+                </a:solidFill>
+                <a:latin typeface="Calibri" pitchFamily="34" charset="0"/>
+                <a:ea typeface="Calibri" pitchFamily="34" charset="-122"/>
+                <a:cs typeface="Calibri" pitchFamily="34" charset="-120"/>
+              </a:rPr>
+              <a:t>ML-based tamper detection, cross-document anomaly scoring, real-time fraud alerts</a:t>
+            </a:r>
+            <a:endParaRPr lang="en-US" sz="1000" dirty="0"/>
+          </a:p>
+        </p:txBody>
+      </p:sp>
+      <p:sp>
+        <p:nvSpPr>
+          <p:cNvPr id="15" name="Shape 13"/>
+          <p:cNvSpPr/>
+          <p:nvPr/>
+        </p:nvSpPr>
+        <p:spPr>
+          <a:xfrm>
+            <a:off x="640080" y="2926080"/>
+            <a:ext cx="7863840" cy="731520"/>
+          </a:xfrm>
+          <a:prstGeom prst="roundRect">
+            <a:avLst>
+              <a:gd name="adj" fmla="val 10000"/>
+            </a:avLst>
+          </a:prstGeom>
+          <a:solidFill>
+            <a:srgbClr val="F4F5F7"/>
+          </a:solidFill>
+          <a:ln/>
+          <a:effectLst>
+            <a:outerShdw sx="100000" sy="100000" kx="0" ky="0" algn="bl" rotWithShape="0" blurRad="50800" dist="12700" dir="8100000">
+              <a:srgbClr val="000000">
+                <a:alpha val="8000"/>
+              </a:srgbClr>
+            </a:outerShdw>
+          </a:effectLst>
+        </p:spPr>
+      </p:sp>
+      <p:sp>
+        <p:nvSpPr>
+          <p:cNvPr id="16" name="Shape 14"/>
+          <p:cNvSpPr/>
+          <p:nvPr/>
+        </p:nvSpPr>
+        <p:spPr>
+          <a:xfrm>
+            <a:off x="822960" y="3063240"/>
+            <a:ext cx="502920" cy="457200"/>
+          </a:xfrm>
+          <a:prstGeom prst="roundRect">
+            <a:avLst>
+              <a:gd name="adj" fmla="val 10000"/>
+            </a:avLst>
+          </a:prstGeom>
+          <a:solidFill>
+            <a:srgbClr val="16A34A"/>
+          </a:solidFill>
+          <a:ln/>
+        </p:spPr>
+      </p:sp>
+      <p:sp>
+        <p:nvSpPr>
+          <p:cNvPr id="17" name="Text 15"/>
+          <p:cNvSpPr/>
+          <p:nvPr/>
+        </p:nvSpPr>
+        <p:spPr>
+          <a:xfrm>
+            <a:off x="822960" y="3063240"/>
+            <a:ext cx="502920" cy="457200"/>
+          </a:xfrm>
+          <a:prstGeom prst="rect">
+            <a:avLst/>
+          </a:prstGeom>
+          <a:noFill/>
+          <a:ln/>
+        </p:spPr>
+        <p:txBody>
+          <a:bodyPr wrap="square" lIns="0" tIns="0" rIns="0" bIns="0" rtlCol="0" anchor="ctr"/>
+          <a:lstStyle/>
+          <a:p>
+            <a:pPr algn="ctr" indent="0" marL="0">
+              <a:buNone/>
+            </a:pPr>
+            <a:r>
+              <a:rPr lang="en-US" sz="1100" b="1" dirty="0">
+                <a:solidFill>
+                  <a:srgbClr val="FFFFFF"/>
+                </a:solidFill>
+                <a:latin typeface="Arial" pitchFamily="34" charset="0"/>
+                <a:ea typeface="Arial" pitchFamily="34" charset="-122"/>
+                <a:cs typeface="Arial" pitchFamily="34" charset="-120"/>
+              </a:rPr>
+              <a:t>P3</a:t>
+            </a:r>
+            <a:endParaRPr lang="en-US" sz="1100" dirty="0"/>
+          </a:p>
+        </p:txBody>
+      </p:sp>
+      <p:sp>
+        <p:nvSpPr>
+          <p:cNvPr id="18" name="Text 16"/>
+          <p:cNvSpPr/>
+          <p:nvPr/>
+        </p:nvSpPr>
+        <p:spPr>
+          <a:xfrm>
+            <a:off x="1508760" y="3035808"/>
+            <a:ext cx="3657600" cy="274320"/>
+          </a:xfrm>
+          <a:prstGeom prst="rect">
+            <a:avLst/>
+          </a:prstGeom>
+          <a:noFill/>
+          <a:ln/>
+        </p:spPr>
+        <p:txBody>
+          <a:bodyPr wrap="square" lIns="0" tIns="0" rIns="0" bIns="0" rtlCol="0" anchor="ctr"/>
+          <a:lstStyle/>
+          <a:p>
+            <a:pPr indent="0" marL="0">
+              <a:buNone/>
+            </a:pPr>
+            <a:r>
+              <a:rPr lang="en-US" sz="1300" b="1" dirty="0">
+                <a:solidFill>
+                  <a:srgbClr val="111827"/>
+                </a:solidFill>
+                <a:latin typeface="Arial" pitchFamily="34" charset="0"/>
+                <a:ea typeface="Arial" pitchFamily="34" charset="-122"/>
+                <a:cs typeface="Arial" pitchFamily="34" charset="-120"/>
+              </a:rPr>
+              <a:t>Extend learning loop</a:t>
+            </a:r>
+            <a:endParaRPr lang="en-US" sz="1300" dirty="0"/>
+          </a:p>
+        </p:txBody>
+      </p:sp>
+      <p:sp>
+        <p:nvSpPr>
+          <p:cNvPr id="19" name="Text 17"/>
+          <p:cNvSpPr/>
+          <p:nvPr/>
+        </p:nvSpPr>
+        <p:spPr>
+          <a:xfrm>
+            <a:off x="1508760" y="3310128"/>
+            <a:ext cx="6766560" cy="274320"/>
+          </a:xfrm>
+          <a:prstGeom prst="rect">
+            <a:avLst/>
+          </a:prstGeom>
+          <a:noFill/>
+          <a:ln/>
+        </p:spPr>
+        <p:txBody>
+          <a:bodyPr wrap="square" lIns="0" tIns="0" rIns="0" bIns="0" rtlCol="0" anchor="ctr"/>
+          <a:lstStyle/>
+          <a:p>
+            <a:pPr indent="0" marL="0">
+              <a:buNone/>
+            </a:pPr>
+            <a:r>
+              <a:rPr lang="en-US" sz="1000" dirty="0">
+                <a:solidFill>
+                  <a:srgbClr val="6B7280"/>
+                </a:solidFill>
+                <a:latin typeface="Calibri" pitchFamily="34" charset="0"/>
+                <a:ea typeface="Calibri" pitchFamily="34" charset="-122"/>
+                <a:cs typeface="Calibri" pitchFamily="34" charset="-120"/>
+              </a:rPr>
+              <a:t>Promote LLM-text formats into learned recipes; extend to GST/ITR/KYC</a:t>
+            </a:r>
+            <a:endParaRPr lang="en-US" sz="1000" dirty="0"/>
+          </a:p>
+        </p:txBody>
+      </p:sp>
+      <p:sp>
+        <p:nvSpPr>
+          <p:cNvPr id="20" name="Shape 18"/>
+          <p:cNvSpPr/>
+          <p:nvPr/>
+        </p:nvSpPr>
+        <p:spPr>
+          <a:xfrm>
+            <a:off x="640080" y="3794760"/>
+            <a:ext cx="7863840" cy="731520"/>
+          </a:xfrm>
+          <a:prstGeom prst="roundRect">
+            <a:avLst>
+              <a:gd name="adj" fmla="val 10000"/>
+            </a:avLst>
+          </a:prstGeom>
+          <a:solidFill>
+            <a:srgbClr val="F4F5F7"/>
+          </a:solidFill>
+          <a:ln/>
+          <a:effectLst>
+            <a:outerShdw sx="100000" sy="100000" kx="0" ky="0" algn="bl" rotWithShape="0" blurRad="50800" dist="12700" dir="8100000">
+              <a:srgbClr val="000000">
+                <a:alpha val="8000"/>
+              </a:srgbClr>
+            </a:outerShdw>
+          </a:effectLst>
+        </p:spPr>
+      </p:sp>
+      <p:sp>
+        <p:nvSpPr>
+          <p:cNvPr id="21" name="Shape 19"/>
+          <p:cNvSpPr/>
+          <p:nvPr/>
+        </p:nvSpPr>
+        <p:spPr>
+          <a:xfrm>
+            <a:off x="822960" y="3931920"/>
+            <a:ext cx="502920" cy="457200"/>
+          </a:xfrm>
+          <a:prstGeom prst="roundRect">
+            <a:avLst>
+              <a:gd name="adj" fmla="val 10000"/>
+            </a:avLst>
+          </a:prstGeom>
+          <a:solidFill>
+            <a:srgbClr val="6B7280"/>
+          </a:solidFill>
+          <a:ln/>
+        </p:spPr>
+      </p:sp>
+      <p:sp>
+        <p:nvSpPr>
+          <p:cNvPr id="22" name="Text 20"/>
+          <p:cNvSpPr/>
+          <p:nvPr/>
+        </p:nvSpPr>
+        <p:spPr>
+          <a:xfrm>
+            <a:off x="822960" y="3931920"/>
+            <a:ext cx="502920" cy="457200"/>
+          </a:xfrm>
+          <a:prstGeom prst="rect">
+            <a:avLst/>
+          </a:prstGeom>
+          <a:noFill/>
+          <a:ln/>
+        </p:spPr>
+        <p:txBody>
+          <a:bodyPr wrap="square" lIns="0" tIns="0" rIns="0" bIns="0" rtlCol="0" anchor="ctr"/>
+          <a:lstStyle/>
+          <a:p>
+            <a:pPr algn="ctr" indent="0" marL="0">
+              <a:buNone/>
+            </a:pPr>
+            <a:r>
+              <a:rPr lang="en-US" sz="1100" b="1" dirty="0">
+                <a:solidFill>
+                  <a:srgbClr val="FFFFFF"/>
+                </a:solidFill>
+                <a:latin typeface="Arial" pitchFamily="34" charset="0"/>
+                <a:ea typeface="Arial" pitchFamily="34" charset="-122"/>
+                <a:cs typeface="Arial" pitchFamily="34" charset="-120"/>
+              </a:rPr>
+              <a:t>P4</a:t>
+            </a:r>
+            <a:endParaRPr lang="en-US" sz="1100" dirty="0"/>
+          </a:p>
+        </p:txBody>
+      </p:sp>
+      <p:sp>
+        <p:nvSpPr>
+          <p:cNvPr id="23" name="Text 21"/>
+          <p:cNvSpPr/>
+          <p:nvPr/>
+        </p:nvSpPr>
+        <p:spPr>
+          <a:xfrm>
+            <a:off x="1508760" y="3904488"/>
+            <a:ext cx="3657600" cy="274320"/>
+          </a:xfrm>
+          <a:prstGeom prst="rect">
+            <a:avLst/>
+          </a:prstGeom>
+          <a:noFill/>
+          <a:ln/>
+        </p:spPr>
+        <p:txBody>
+          <a:bodyPr wrap="square" lIns="0" tIns="0" rIns="0" bIns="0" rtlCol="0" anchor="ctr"/>
+          <a:lstStyle/>
+          <a:p>
+            <a:pPr indent="0" marL="0">
+              <a:buNone/>
+            </a:pPr>
+            <a:r>
+              <a:rPr lang="en-US" sz="1300" b="1" dirty="0">
+                <a:solidFill>
+                  <a:srgbClr val="111827"/>
+                </a:solidFill>
+                <a:latin typeface="Arial" pitchFamily="34" charset="0"/>
+                <a:ea typeface="Arial" pitchFamily="34" charset="-122"/>
+                <a:cs typeface="Arial" pitchFamily="34" charset="-120"/>
+              </a:rPr>
+              <a:t>CE password affordance</a:t>
+            </a:r>
+            <a:endParaRPr lang="en-US" sz="1300" dirty="0"/>
+          </a:p>
+        </p:txBody>
+      </p:sp>
+      <p:sp>
+        <p:nvSpPr>
+          <p:cNvPr id="24" name="Text 22"/>
+          <p:cNvSpPr/>
+          <p:nvPr/>
+        </p:nvSpPr>
+        <p:spPr>
+          <a:xfrm>
+            <a:off x="1508760" y="4178808"/>
+            <a:ext cx="6766560" cy="274320"/>
+          </a:xfrm>
+          <a:prstGeom prst="rect">
+            <a:avLst/>
+          </a:prstGeom>
+          <a:noFill/>
+          <a:ln/>
+        </p:spPr>
+        <p:txBody>
+          <a:bodyPr wrap="square" lIns="0" tIns="0" rIns="0" bIns="0" rtlCol="0" anchor="ctr"/>
+          <a:lstStyle/>
+          <a:p>
+            <a:pPr indent="0" marL="0">
+              <a:buNone/>
+            </a:pPr>
+            <a:r>
+              <a:rPr lang="en-US" sz="1000" dirty="0">
+                <a:solidFill>
+                  <a:srgbClr val="6B7280"/>
+                </a:solidFill>
+                <a:latin typeface="Calibri" pitchFamily="34" charset="0"/>
+                <a:ea typeface="Calibri" pitchFamily="34" charset="-122"/>
+                <a:cs typeface="Calibri" pitchFamily="34" charset="-120"/>
+              </a:rPr>
+              <a:t>CE-supplied passwords for PDFs no identity-derived candidate unlocks</a:t>
+            </a:r>
+            <a:endParaRPr lang="en-US" sz="1000" dirty="0"/>
+          </a:p>
+        </p:txBody>
+      </p:sp>
+      <p:sp>
+        <p:nvSpPr>
+          <p:cNvPr id="25" name="Shape 23"/>
+          <p:cNvSpPr/>
+          <p:nvPr/>
+        </p:nvSpPr>
+        <p:spPr>
+          <a:xfrm>
+            <a:off x="2286000" y="4572000"/>
+            <a:ext cx="4572000" cy="411480"/>
+          </a:xfrm>
+          <a:prstGeom prst="roundRect">
+            <a:avLst>
+              <a:gd name="adj" fmla="val 17778"/>
+            </a:avLst>
+          </a:prstGeom>
+          <a:solidFill>
+            <a:srgbClr val="EBF5FF"/>
+          </a:solidFill>
+          <a:ln/>
+          <a:effectLst>
+            <a:outerShdw sx="100000" sy="100000" kx="0" ky="0" algn="bl" rotWithShape="0" blurRad="50800" dist="12700" dir="8100000">
+              <a:srgbClr val="000000">
+                <a:alpha val="8000"/>
+              </a:srgbClr>
+            </a:outerShdw>
+          </a:effectLst>
+        </p:spPr>
+      </p:sp>
+      <p:sp>
+        <p:nvSpPr>
+          <p:cNvPr id="26" name="Text 24"/>
+          <p:cNvSpPr/>
+          <p:nvPr/>
+        </p:nvSpPr>
+        <p:spPr>
+          <a:xfrm>
+            <a:off x="2286000" y="4572000"/>
+            <a:ext cx="4572000" cy="411480"/>
+          </a:xfrm>
+          <a:prstGeom prst="rect">
+            <a:avLst/>
+          </a:prstGeom>
+          <a:noFill/>
+          <a:ln/>
+        </p:spPr>
+        <p:txBody>
+          <a:bodyPr wrap="square" lIns="0" tIns="0" rIns="0" bIns="0" rtlCol="0" anchor="ctr"/>
+          <a:lstStyle/>
+          <a:p>
+            <a:pPr algn="ctr" indent="0" marL="0">
+              <a:buNone/>
+            </a:pPr>
+            <a:r>
+              <a:rPr lang="en-US" sz="1300" b="1" dirty="0">
+                <a:solidFill>
+                  <a:srgbClr val="2563EB"/>
+                </a:solidFill>
+                <a:latin typeface="Arial" pitchFamily="34" charset="0"/>
+                <a:ea typeface="Arial" pitchFamily="34" charset="-122"/>
+                <a:cs typeface="Arial" pitchFamily="34" charset="-120"/>
+              </a:rPr>
+              <a:t>Ask: Pilot on a live queue to quantify hours saved</a:t>
+            </a:r>
+            <a:endParaRPr lang="en-US" sz="1300" dirty="0"/>
+          </a:p>
+        </p:txBody>
+      </p:sp>
+    </p:spTree>
+  </p:cSld>
+  <p:clrMapOvr>
+    <a:masterClrMapping/>
+  </p:clrMapOvr>
+</p:sld>
+</file>
+
+<file path=ppt/slides/slide15.xml><?xml version="1.0" encoding="utf-8"?>
+<p:sld xmlns:a="http://schemas.openxmlformats.org/drawingml/2006/main" xmlns:r="http://schemas.openxmlformats.org/officeDocument/2006/relationships" xmlns:p="http://schemas.openxmlformats.org/presentationml/2006/main">
+  <p:cSld name="Slide 15">
     <p:bg>
       <p:bgPr>
         <a:solidFill>
@@ -4288,7 +5927,7 @@
                 <a:ea typeface="Calibri" pitchFamily="34" charset="-122"/>
                 <a:cs typeface="Calibri" pitchFamily="34" charset="-120"/>
               </a:rPr>
-              <a:t>13</a:t>
+              <a:t>15</a:t>
             </a:r>
             <a:endParaRPr lang="en-US" sz="900" dirty="0"/>
           </a:p>
@@ -4677,7 +6316,7 @@
                 <a:ea typeface="Arial" pitchFamily="34" charset="-122"/>
                 <a:cs typeface="Arial" pitchFamily="34" charset="-120"/>
               </a:rPr>
-              <a:t>Portal</a:t>
+              <a:t>Fraud Engine</a:t>
             </a:r>
             <a:endParaRPr lang="en-US" sz="1200" dirty="0"/>
           </a:p>
@@ -4716,7 +6355,7 @@
                 <a:ea typeface="Calibri" pitchFamily="34" charset="-122"/>
                 <a:cs typeface="Calibri" pitchFamily="34" charset="-120"/>
               </a:rPr>
-              <a:t>22-tab CAM view · 25-sheet parser · ~2,000 editable fields/CAM · 11 test cases</a:t>
+              <a:t>Balance reconciliation · PAN/GSTIN cross-check · Name match · Document completeness</a:t>
             </a:r>
             <a:endParaRPr lang="en-US" sz="1000" dirty="0"/>
           </a:p>
@@ -4724,7 +6363,114 @@
       </p:sp>
       <p:sp>
         <p:nvSpPr>
-          <p:cNvPr id="16" name="Text 14"/>
+          <p:cNvPr id="16" name="Shape 14"/>
+          <p:cNvSpPr/>
+          <p:nvPr/>
+        </p:nvSpPr>
+        <p:spPr>
+          <a:xfrm>
+            <a:off x="731520" y="4846320"/>
+            <a:ext cx="7680960" cy="731520"/>
+          </a:xfrm>
+          <a:prstGeom prst="roundRect">
+            <a:avLst>
+              <a:gd name="adj" fmla="val 10000"/>
+            </a:avLst>
+          </a:prstGeom>
+          <a:solidFill>
+            <a:srgbClr val="1A2040"/>
+          </a:solidFill>
+          <a:ln/>
+          <a:effectLst>
+            <a:outerShdw sx="100000" sy="100000" kx="0" ky="0" algn="bl" rotWithShape="0" blurRad="50800" dist="12700" dir="8100000">
+              <a:srgbClr val="000000">
+                <a:alpha val="8000"/>
+              </a:srgbClr>
+            </a:outerShdw>
+          </a:effectLst>
+        </p:spPr>
+      </p:sp>
+      <p:sp>
+        <p:nvSpPr>
+          <p:cNvPr id="17" name="Text 15"/>
+          <p:cNvSpPr/>
+          <p:nvPr/>
+        </p:nvSpPr>
+        <p:spPr>
+          <a:xfrm>
+            <a:off x="914400" y="4937760"/>
+            <a:ext cx="1828800" cy="228600"/>
+          </a:xfrm>
+          <a:prstGeom prst="rect">
+            <a:avLst/>
+          </a:prstGeom>
+          <a:noFill/>
+          <a:ln/>
+        </p:spPr>
+        <p:txBody>
+          <a:bodyPr wrap="square" lIns="0" tIns="0" rIns="0" bIns="0" rtlCol="0" anchor="ctr"/>
+          <a:lstStyle/>
+          <a:p>
+            <a:pPr indent="0" marL="0">
+              <a:buNone/>
+            </a:pPr>
+            <a:r>
+              <a:rPr lang="en-US" sz="1200" b="1" dirty="0">
+                <a:solidFill>
+                  <a:srgbClr val="3B82F6"/>
+                </a:solidFill>
+                <a:latin typeface="Arial" pitchFamily="34" charset="0"/>
+                <a:ea typeface="Arial" pitchFamily="34" charset="-122"/>
+                <a:cs typeface="Arial" pitchFamily="34" charset="-120"/>
+              </a:rPr>
+              <a:t>Portal</a:t>
+            </a:r>
+            <a:endParaRPr lang="en-US" sz="1200" dirty="0"/>
+          </a:p>
+        </p:txBody>
+      </p:sp>
+      <p:sp>
+        <p:nvSpPr>
+          <p:cNvPr id="18" name="Text 16"/>
+          <p:cNvSpPr/>
+          <p:nvPr/>
+        </p:nvSpPr>
+        <p:spPr>
+          <a:xfrm>
+            <a:off x="914400" y="5193792"/>
+            <a:ext cx="7315200" cy="274320"/>
+          </a:xfrm>
+          <a:prstGeom prst="rect">
+            <a:avLst/>
+          </a:prstGeom>
+          <a:noFill/>
+          <a:ln/>
+        </p:spPr>
+        <p:txBody>
+          <a:bodyPr wrap="square" lIns="0" tIns="0" rIns="0" bIns="0" rtlCol="0" anchor="ctr"/>
+          <a:lstStyle/>
+          <a:p>
+            <a:pPr indent="0" marL="0">
+              <a:buNone/>
+            </a:pPr>
+            <a:r>
+              <a:rPr lang="en-US" sz="1000" dirty="0">
+                <a:solidFill>
+                  <a:srgbClr val="CADCFC"/>
+                </a:solidFill>
+                <a:latin typeface="Calibri" pitchFamily="34" charset="0"/>
+                <a:ea typeface="Calibri" pitchFamily="34" charset="-122"/>
+                <a:cs typeface="Calibri" pitchFamily="34" charset="-120"/>
+              </a:rPr>
+              <a:t>22-tab CAM view · 25-sheet parser · ~2,000 editable fields/CAM · Fraud attention panel</a:t>
+            </a:r>
+            <a:endParaRPr lang="en-US" sz="1000" dirty="0"/>
+          </a:p>
+        </p:txBody>
+      </p:sp>
+      <p:sp>
+        <p:nvSpPr>
+          <p:cNvPr id="19" name="Text 17"/>
           <p:cNvSpPr/>
           <p:nvPr/>
         </p:nvSpPr>

</xml_diff>